<commit_message>
Deck: Pareto-front slide (coupling vs Ms, hull in colour) and clearer wording in the one-page flowchart boxes
Co-Authored-By: Claude Fable 5.1 <noreply@anthropic.com>
</commit_message>
<xml_diff>
--- a/MAGNITO_Fe-HREE_screening.pptx
+++ b/MAGNITO_Fe-HREE_screening.pptx
@@ -34,9 +34,10 @@
     <p:sldId id="282" r:id="rId28"/>
     <p:sldId id="283" r:id="rId29"/>
     <p:sldId id="284" r:id="rId30"/>
+    <p:sldId id="285" r:id="rId31"/>
   </p:sldIdLst>
   <p:notesMasterIdLst>
-    <p:notesMasterId r:id="rId31"/>
+    <p:notesMasterId r:id="rId32"/>
   </p:notesMasterIdLst>
   <p:sldSz cx="12192000" cy="6858000"/>
   <p:notesSz cx="6858000" cy="12192000"/>
@@ -2378,7 +2379,7 @@
           <a:p>
             <a:r>
               <a:rPr lang="en-US" dirty="0"/>
-              <a:t>GP: use h-based linear mean, Matern kernel on standardised descriptors; batch acquisition with diversity penalty sized to the packed job. Causal: DAG host-geometry -&gt; S5d -&gt; gap; Fe density -&gt; Ms; interstitial site -&gt; S5d. Generative: MatterGen-style conditioned on composition and target Fe density.</a:t>
+              <a:t/>
             </a:r>
             <a:endParaRPr lang="en-US" dirty="0"/>
           </a:p>
@@ -2490,6 +2491,94 @@
             <a:fld id="{F7021451-1387-4CA6-816F-3879F97B5CBC}" type="slidenum">
               <a:rPr lang="en-US"/>
               <a:t>3</a:t>
+            </a:fld>
+            <a:endParaRPr lang="en-US"/>
+          </a:p>
+        </p:txBody>
+      </p:sp>
+    </p:spTree>
+    <p:extLst>
+      <p:ext uri="{BB962C8B-B14F-4D97-AF65-F5344CB8AC3E}">
+        <p14:creationId xmlns:p14="http://schemas.microsoft.com/office/powerpoint/2010/main" val="1024086991"/>
+      </p:ext>
+    </p:extLst>
+  </p:cSld>
+  <p:clrMapOvr>
+    <a:masterClrMapping/>
+  </p:clrMapOvr>
+</p:notes>
+</file>
+
+<file path=ppt/notesSlides/notesSlide30.xml><?xml version="1.0" encoding="utf-8"?>
+<p:notes xmlns:a="http://schemas.openxmlformats.org/drawingml/2006/main" xmlns:r="http://schemas.openxmlformats.org/officeDocument/2006/relationships" xmlns:p="http://schemas.openxmlformats.org/presentationml/2006/main">
+  <p:cSld>
+    <p:spTree>
+      <p:nvGrpSpPr>
+        <p:cNvPr id="1" name=""/>
+        <p:cNvGrpSpPr/>
+        <p:nvPr/>
+      </p:nvGrpSpPr>
+      <p:grpSpPr>
+        <a:xfrm>
+          <a:off x="0" y="0"/>
+          <a:ext cx="0" cy="0"/>
+          <a:chOff x="0" y="0"/>
+          <a:chExt cx="0" cy="0"/>
+        </a:xfrm>
+      </p:grpSpPr>
+      <p:sp>
+        <p:nvSpPr>
+          <p:cNvPr id="2" name="Slide Image Placeholder 1"/>
+          <p:cNvSpPr>
+            <a:spLocks noGrp="1" noRot="1" noChangeAspect="1"/>
+          </p:cNvSpPr>
+          <p:nvPr>
+            <p:ph type="sldImg"/>
+          </p:nvPr>
+        </p:nvSpPr>
+        <p:spPr/>
+      </p:sp>
+      <p:sp>
+        <p:nvSpPr>
+          <p:cNvPr id="3" name="Notes Placeholder 2"/>
+          <p:cNvSpPr>
+            <a:spLocks noGrp="1"/>
+          </p:cNvSpPr>
+          <p:nvPr>
+            <p:ph type="body" idx="1"/>
+          </p:nvPr>
+        </p:nvSpPr>
+        <p:spPr/>
+        <p:txBody>
+          <a:bodyPr/>
+          <a:lstStyle/>
+          <a:p>
+            <a:r>
+              <a:rPr lang="en-US" dirty="0"/>
+              <a:t>GP: use h-based linear mean, Matern kernel on standardised descriptors; batch acquisition with diversity penalty sized to the packed job. Causal: DAG host-geometry -&gt; S5d -&gt; gap; Fe density -&gt; Ms; interstitial site -&gt; S5d. Generative: MatterGen-style conditioned on composition and target Fe density.</a:t>
+            </a:r>
+            <a:endParaRPr lang="en-US" dirty="0"/>
+          </a:p>
+        </p:txBody>
+      </p:sp>
+      <p:sp>
+        <p:nvSpPr>
+          <p:cNvPr id="4" name="Slide Number Placeholder 3"/>
+          <p:cNvSpPr>
+            <a:spLocks noGrp="1"/>
+          </p:cNvSpPr>
+          <p:nvPr>
+            <p:ph type="sldNum" sz="quarter" idx="10"/>
+          </p:nvPr>
+        </p:nvSpPr>
+        <p:spPr/>
+        <p:txBody>
+          <a:bodyPr/>
+          <a:lstStyle/>
+          <a:p>
+            <a:fld id="{F7021451-1387-4CA6-816F-3879F97B5CBC}" type="slidenum">
+              <a:rPr lang="en-US"/>
+              <a:t>30</a:t>
             </a:fld>
             <a:endParaRPr lang="en-US"/>
           </a:p>
@@ -26588,7 +26677,7 @@
                 <a:ea typeface="Calibri" pitchFamily="34" charset="-122"/>
                 <a:cs typeface="Calibri" pitchFamily="34" charset="-120"/>
               </a:rPr>
-              <a:t>GP on h</a:t>
+              <a:t>GP predicts h</a:t>
             </a:r>
             <a:endParaRPr lang="en-US" sz="1000" dirty="0"/>
           </a:p>
@@ -26605,7 +26694,7 @@
                 <a:ea typeface="Calibri" pitchFamily="34" charset="-122"/>
                 <a:cs typeface="Calibri" pitchFamily="34" charset="-120"/>
               </a:rPr>
-              <a:t>ridge mean +</a:t>
+              <a:t>(5d polarisation):</a:t>
             </a:r>
             <a:endParaRPr lang="en-US" sz="1000" dirty="0"/>
           </a:p>
@@ -26622,7 +26711,7 @@
                 <a:ea typeface="Calibri" pitchFamily="34" charset="-122"/>
                 <a:cs typeface="Calibri" pitchFamily="34" charset="-120"/>
               </a:rPr>
-              <a:t>Matern residual</a:t>
+              <a:t>linear trend + GP correction</a:t>
             </a:r>
             <a:endParaRPr lang="en-US" sz="1000" dirty="0"/>
           </a:p>
@@ -26978,7 +27067,7 @@
                 <a:ea typeface="Calibri" pitchFamily="34" charset="-122"/>
                 <a:cs typeface="Calibri" pitchFamily="34" charset="-120"/>
               </a:rPr>
-              <a:t>per run: h, Fe/Co moments,</a:t>
+              <a:t>per run: h, Fe/Co moments, V</a:t>
             </a:r>
             <a:endParaRPr lang="en-US" sz="1000" dirty="0"/>
           </a:p>
@@ -26995,7 +27084,24 @@
                 <a:ea typeface="Calibri" pitchFamily="34" charset="-122"/>
                 <a:cs typeface="Calibri" pitchFamily="34" charset="-120"/>
               </a:rPr>
-              <a:t>volume → gap_RE, T*, Ms</a:t>
+              <a:t>→ gap_RE = 1574·h·(gJ−1)J/3.5</a:t>
+            </a:r>
+            <a:endParaRPr lang="en-US" sz="1000" dirty="0"/>
+          </a:p>
+          <a:p>
+            <a:pPr algn="ctr" indent="0" marL="0">
+              <a:buNone/>
+            </a:pPr>
+            <a:r>
+              <a:rPr lang="en-US" sz="1000" dirty="0">
+                <a:solidFill>
+                  <a:srgbClr val="1F5F7A"/>
+                </a:solidFill>
+                <a:latin typeface="Calibri" pitchFamily="34" charset="0"/>
+                <a:ea typeface="Calibri" pitchFamily="34" charset="-122"/>
+                <a:cs typeface="Calibri" pitchFamily="34" charset="-120"/>
+              </a:rPr>
+              <a:t>T* = gap_RE/2k_B, Ms = Σm/V</a:t>
             </a:r>
             <a:endParaRPr lang="en-US" sz="1000" dirty="0"/>
           </a:p>
@@ -27059,7 +27165,7 @@
                 <a:ea typeface="Calibri" pitchFamily="34" charset="-122"/>
                 <a:cs typeface="Calibri" pitchFamily="34" charset="-120"/>
               </a:rPr>
-              <a:t>ingest</a:t>
+              <a:t>ingest: parse OUTCARs →</a:t>
             </a:r>
             <a:endParaRPr lang="en-US" sz="1000" dirty="0"/>
           </a:p>
@@ -27076,7 +27182,7 @@
                 <a:ea typeface="Calibri" pitchFamily="34" charset="-122"/>
                 <a:cs typeface="Calibri" pitchFamily="34" charset="-120"/>
               </a:rPr>
-              <a:t>labels.csv · H1 check</a:t>
+              <a:t>labels.csv; compare measured h</a:t>
             </a:r>
             <a:endParaRPr lang="en-US" sz="1000" dirty="0"/>
           </a:p>
@@ -27093,7 +27199,7 @@
                 <a:ea typeface="Calibri" pitchFamily="34" charset="-122"/>
                 <a:cs typeface="Calibri" pitchFamily="34" charset="-120"/>
               </a:rPr>
-              <a:t>GP re-fit</a:t>
+              <a:t>to predicted (H1); re-fit GP</a:t>
             </a:r>
             <a:endParaRPr lang="en-US" sz="1000" dirty="0"/>
           </a:p>
@@ -27157,7 +27263,7 @@
                 <a:ea typeface="Calibri" pitchFamily="34" charset="-122"/>
                 <a:cs typeface="Calibri" pitchFamily="34" charset="-120"/>
               </a:rPr>
-              <a:t>front moved?</a:t>
+              <a:t>Pareto front</a:t>
             </a:r>
             <a:endParaRPr lang="en-US" sz="1000" dirty="0"/>
           </a:p>
@@ -27174,7 +27280,24 @@
                 <a:ea typeface="Calibri" pitchFamily="34" charset="-122"/>
                 <a:cs typeface="Calibri" pitchFamily="34" charset="-120"/>
               </a:rPr>
-              <a:t>feasible left?</a:t>
+              <a:t>moved? feasible</a:t>
+            </a:r>
+            <a:endParaRPr lang="en-US" sz="1000" dirty="0"/>
+          </a:p>
+          <a:p>
+            <a:pPr algn="ctr" indent="0" marL="0">
+              <a:buNone/>
+            </a:pPr>
+            <a:r>
+              <a:rPr lang="en-US" sz="1000" dirty="0">
+                <a:solidFill>
+                  <a:srgbClr val="8A3B2E"/>
+                </a:solidFill>
+                <a:latin typeface="Calibri" pitchFamily="34" charset="0"/>
+                <a:ea typeface="Calibri" pitchFamily="34" charset="-122"/>
+                <a:cs typeface="Calibri" pitchFamily="34" charset="-120"/>
+              </a:rPr>
+              <a:t>candidates left?</a:t>
             </a:r>
             <a:endParaRPr lang="en-US" sz="1000" dirty="0"/>
           </a:p>
@@ -33892,13 +34015,6 @@
 <file path=ppt/slides/slide29.xml><?xml version="1.0" encoding="utf-8"?>
 <p:sld xmlns:a="http://schemas.openxmlformats.org/drawingml/2006/main" xmlns:r="http://schemas.openxmlformats.org/officeDocument/2006/relationships" xmlns:p="http://schemas.openxmlformats.org/presentationml/2006/main">
   <p:cSld name="Slide 29">
-    <p:bg>
-      <p:bgPr>
-        <a:solidFill>
-          <a:srgbClr val="101B33"/>
-        </a:solidFill>
-      </p:bgPr>
-    </p:bg>
     <p:spTree>
       <p:nvGrpSpPr>
         <p:cNvPr id="1" name=""/>
@@ -33940,13 +34056,13 @@
             <a:r>
               <a:rPr lang="en-US" sz="1200" b="1" spc="200" kern="0" dirty="0">
                 <a:solidFill>
-                  <a:srgbClr val="F2B134"/>
-                </a:solidFill>
-                <a:latin typeface="Calibri" pitchFamily="34" charset="0"/>
-                <a:ea typeface="Calibri" pitchFamily="34" charset="-122"/>
-                <a:cs typeface="Calibri" pitchFamily="34" charset="-120"/>
-              </a:rPr>
-              <a:t>CLOSING THE LOOP</a:t>
+                  <a:srgbClr val="E4572E"/>
+                </a:solidFill>
+                <a:latin typeface="Calibri" pitchFamily="34" charset="0"/>
+                <a:ea typeface="Calibri" pitchFamily="34" charset="-122"/>
+                <a:cs typeface="Calibri" pitchFamily="34" charset="-120"/>
+              </a:rPr>
+              <a:t>THE PARETO FRONT, DRAWN</a:t>
             </a:r>
             <a:endParaRPr lang="en-US" sz="1200" dirty="0"/>
           </a:p>
@@ -33979,50 +34095,74 @@
             <a:r>
               <a:rPr lang="en-US" sz="3200" b="1" dirty="0">
                 <a:solidFill>
-                  <a:srgbClr val="FFFFFF"/>
+                  <a:srgbClr val="1A2233"/>
                 </a:solidFill>
                 <a:latin typeface="Cambria" pitchFamily="34" charset="0"/>
                 <a:ea typeface="Cambria" pitchFamily="34" charset="-122"/>
                 <a:cs typeface="Cambria" pitchFamily="34" charset="-120"/>
               </a:rPr>
-              <a:t>Gaussian process for where to look, causal model for which lever, generative model for what to propose</a:t>
+              <a:t>What 'front moved?' means: the set of hosts no other host beats on both coupling and magnetisation</a:t>
             </a:r>
             <a:endParaRPr lang="en-US" sz="3200" dirty="0"/>
           </a:p>
         </p:txBody>
       </p:sp>
-      <p:sp>
-        <p:nvSpPr>
-          <p:cNvPr id="4" name="Shape 2"/>
+      <p:pic>
+        <p:nvPicPr>
+          <p:cNvPr id="4" name="Image 0" descr="/Users/g5q/Documents/GitHub/gnome-fe-hree-magnets/assets/pareto_front.png">    </p:cNvPr>
+          <p:cNvPicPr>
+            <a:picLocks noChangeAspect="1"/>
+          </p:cNvPicPr>
+          <p:nvPr/>
+        </p:nvPicPr>
+        <p:blipFill>
+          <a:blip r:embed="rId1"/>
+          <a:stretch>
+            <a:fillRect/>
+          </a:stretch>
+        </p:blipFill>
+        <p:spPr>
+          <a:xfrm>
+            <a:off x="640080" y="1417320"/>
+            <a:ext cx="6675120" cy="4636008"/>
+          </a:xfrm>
+          <a:prstGeom prst="rect">
+            <a:avLst/>
+          </a:prstGeom>
+        </p:spPr>
+      </p:pic>
+      <p:sp>
+        <p:nvSpPr>
+          <p:cNvPr id="5" name="Shape 2"/>
           <p:cNvSpPr/>
           <p:nvPr/>
         </p:nvSpPr>
         <p:spPr>
           <a:xfrm>
-            <a:off x="640080" y="1600200"/>
-            <a:ext cx="2029968" cy="1783080"/>
+            <a:off x="7589520" y="1417320"/>
+            <a:ext cx="3931920" cy="4636008"/>
           </a:xfrm>
           <a:prstGeom prst="roundRect">
             <a:avLst>
-              <a:gd name="adj" fmla="val 4103"/>
+              <a:gd name="adj" fmla="val 1860"/>
             </a:avLst>
           </a:prstGeom>
           <a:solidFill>
-            <a:srgbClr val="2E86AB"/>
+            <a:srgbClr val="EEF2F7"/>
           </a:solidFill>
           <a:ln/>
         </p:spPr>
       </p:sp>
       <p:sp>
         <p:nvSpPr>
-          <p:cNvPr id="5" name="Text 3"/>
+          <p:cNvPr id="6" name="Text 3"/>
           <p:cNvSpPr txBox="1"/>
           <p:nvPr/>
         </p:nvSpPr>
         <p:spPr>
           <a:xfrm>
-            <a:off x="749808" y="1700784"/>
-            <a:ext cx="1810512" cy="329184"/>
+            <a:off x="7818120" y="1554480"/>
+            <a:ext cx="3566160" cy="237744"/>
           </a:xfrm>
           <a:prstGeom prst="rect">
             <a:avLst/>
@@ -34034,19 +34174,19 @@
           <a:bodyPr wrap="square" lIns="0" tIns="0" rIns="0" bIns="0" rtlCol="0" anchor="ctr"/>
           <a:lstStyle/>
           <a:p>
-            <a:pPr algn="ctr" indent="0" marL="0">
+            <a:pPr indent="0" marL="0">
               <a:buNone/>
             </a:pPr>
             <a:r>
               <a:rPr lang="en-US" sz="1250" b="1" dirty="0">
                 <a:solidFill>
-                  <a:srgbClr val="FFFFFF"/>
-                </a:solidFill>
-                <a:latin typeface="Calibri" pitchFamily="34" charset="0"/>
-                <a:ea typeface="Calibri" pitchFamily="34" charset="-122"/>
-                <a:cs typeface="Calibri" pitchFamily="34" charset="-120"/>
-              </a:rPr>
-              <a:t>Labelled data</a:t>
+                  <a:srgbClr val="1A2233"/>
+                </a:solidFill>
+                <a:latin typeface="Calibri" pitchFamily="34" charset="0"/>
+                <a:ea typeface="Calibri" pitchFamily="34" charset="-122"/>
+                <a:cs typeface="Calibri" pitchFamily="34" charset="-120"/>
+              </a:rPr>
+              <a:t>How to read it</a:t>
             </a:r>
             <a:endParaRPr lang="en-US" sz="1250" dirty="0"/>
           </a:p>
@@ -34054,14 +34194,14 @@
       </p:sp>
       <p:sp>
         <p:nvSpPr>
-          <p:cNvPr id="6" name="Text 4"/>
+          <p:cNvPr id="7" name="Text 4"/>
           <p:cNvSpPr txBox="1"/>
           <p:nvPr/>
         </p:nvSpPr>
         <p:spPr>
           <a:xfrm>
-            <a:off x="749808" y="2066544"/>
-            <a:ext cx="1810512" cy="1261872"/>
+            <a:off x="7818120" y="1828800"/>
+            <a:ext cx="3611880" cy="1234440"/>
           </a:xfrm>
           <a:prstGeom prst="rect">
             <a:avLst/>
@@ -34073,68 +34213,34 @@
           <a:bodyPr wrap="square" lIns="0" tIns="0" rIns="0" bIns="0" rtlCol="0" anchor="ctr"/>
           <a:lstStyle/>
           <a:p>
-            <a:pPr algn="ctr" indent="0" marL="0">
-              <a:buNone/>
-            </a:pPr>
-            <a:r>
-              <a:rPr lang="en-US" sz="860" dirty="0">
-                <a:solidFill>
-                  <a:srgbClr val="F0F4FA"/>
-                </a:solidFill>
-                <a:latin typeface="Calibri" pitchFamily="34" charset="0"/>
-                <a:ea typeface="Calibri" pitchFamily="34" charset="-122"/>
-                <a:cs typeface="Calibri" pitchFamily="34" charset="-120"/>
-              </a:rPr>
-              <a:t>180 Gd pairs → gap, h, moments, geometry</a:t>
-            </a:r>
-            <a:endParaRPr lang="en-US" sz="860" dirty="0"/>
-          </a:p>
-          <a:p>
-            <a:pPr algn="ctr" indent="0" marL="0">
-              <a:buNone/>
-            </a:pPr>
-            <a:r>
-              <a:rPr lang="en-US" sz="860" dirty="0">
-                <a:solidFill>
-                  <a:srgbClr val="F0F4FA"/>
-                </a:solidFill>
-                <a:latin typeface="Calibri" pitchFamily="34" charset="0"/>
-                <a:ea typeface="Calibri" pitchFamily="34" charset="-122"/>
-                <a:cs typeface="Calibri" pitchFamily="34" charset="-120"/>
-              </a:rPr>
-              <a:t>+ 20 light-RE runs</a:t>
-            </a:r>
-            <a:endParaRPr lang="en-US" sz="860" dirty="0"/>
-          </a:p>
-          <a:p>
-            <a:pPr algn="ctr" indent="0" marL="0">
-              <a:buNone/>
-            </a:pPr>
-            <a:r>
-              <a:rPr lang="en-US" sz="860" dirty="0">
-                <a:solidFill>
-                  <a:srgbClr val="F0F4FA"/>
-                </a:solidFill>
-                <a:latin typeface="Calibri" pitchFamily="34" charset="0"/>
-                <a:ea typeface="Calibri" pitchFamily="34" charset="-122"/>
-                <a:cs typeface="Calibri" pitchFamily="34" charset="-120"/>
-              </a:rPr>
-              <a:t>+ MACE hull for every cell</a:t>
-            </a:r>
-            <a:endParaRPr lang="en-US" sz="860" dirty="0"/>
-          </a:p>
-        </p:txBody>
-      </p:sp>
-      <p:sp>
-        <p:nvSpPr>
-          <p:cNvPr id="7" name="Text 5"/>
+            <a:pPr indent="0" marL="0">
+              <a:buNone/>
+            </a:pPr>
+            <a:r>
+              <a:rPr lang="en-US" sz="1000" dirty="0">
+                <a:solidFill>
+                  <a:srgbClr val="5A6478"/>
+                </a:solidFill>
+                <a:latin typeface="Calibri" pitchFamily="34" charset="0"/>
+                <a:ea typeface="Calibri" pitchFamily="34" charset="-122"/>
+                <a:cs typeface="Calibri" pitchFamily="34" charset="-120"/>
+              </a:rPr>
+              <a:t>Every credible host plotted at the coupling it would give Nd (measured Gd gap scaled by (gJ−1)J) against the Ms it would give with Nd. The red line joins the hosts that are not dominated: no other host has both a larger gap and a larger Ms. Colour, where present, is the MACE hull energy of the Nd cell.</a:t>
+            </a:r>
+            <a:endParaRPr lang="en-US" sz="1000" dirty="0"/>
+          </a:p>
+        </p:txBody>
+      </p:sp>
+      <p:sp>
+        <p:nvSpPr>
+          <p:cNvPr id="8" name="Text 5"/>
           <p:cNvSpPr txBox="1"/>
           <p:nvPr/>
         </p:nvSpPr>
         <p:spPr>
           <a:xfrm>
-            <a:off x="2651760" y="2286000"/>
-            <a:ext cx="274320" cy="365760"/>
+            <a:off x="7818120" y="3154680"/>
+            <a:ext cx="3566160" cy="237744"/>
           </a:xfrm>
           <a:prstGeom prst="rect">
             <a:avLst/>
@@ -34146,56 +34252,34 @@
           <a:bodyPr wrap="square" lIns="0" tIns="0" rIns="0" bIns="0" rtlCol="0" anchor="ctr"/>
           <a:lstStyle/>
           <a:p>
-            <a:pPr algn="ctr" indent="0" marL="0">
-              <a:buNone/>
-            </a:pPr>
-            <a:r>
-              <a:rPr lang="en-US" sz="1800" b="1" dirty="0">
-                <a:solidFill>
-                  <a:srgbClr val="8FA3C0"/>
-                </a:solidFill>
-                <a:latin typeface="Arial" pitchFamily="34" charset="0"/>
-                <a:ea typeface="Arial" pitchFamily="34" charset="-122"/>
-                <a:cs typeface="Arial" pitchFamily="34" charset="-120"/>
-              </a:rPr>
-              <a:t>→</a:t>
-            </a:r>
-            <a:endParaRPr lang="en-US" sz="1800" dirty="0"/>
-          </a:p>
-        </p:txBody>
-      </p:sp>
-      <p:sp>
-        <p:nvSpPr>
-          <p:cNvPr id="8" name="Shape 6"/>
-          <p:cNvSpPr/>
-          <p:nvPr/>
-        </p:nvSpPr>
-        <p:spPr>
-          <a:xfrm>
-            <a:off x="2907792" y="1600200"/>
-            <a:ext cx="2029968" cy="1783080"/>
-          </a:xfrm>
-          <a:prstGeom prst="roundRect">
-            <a:avLst>
-              <a:gd name="adj" fmla="val 4103"/>
-            </a:avLst>
-          </a:prstGeom>
-          <a:solidFill>
-            <a:srgbClr val="3E7FA6"/>
-          </a:solidFill>
-          <a:ln/>
-        </p:spPr>
-      </p:sp>
-      <p:sp>
-        <p:nvSpPr>
-          <p:cNvPr id="9" name="Text 7"/>
+            <a:pPr indent="0" marL="0">
+              <a:buNone/>
+            </a:pPr>
+            <a:r>
+              <a:rPr lang="en-US" sz="1250" b="1" dirty="0">
+                <a:solidFill>
+                  <a:srgbClr val="1A2233"/>
+                </a:solidFill>
+                <a:latin typeface="Calibri" pitchFamily="34" charset="0"/>
+                <a:ea typeface="Calibri" pitchFamily="34" charset="-122"/>
+                <a:cs typeface="Calibri" pitchFamily="34" charset="-120"/>
+              </a:rPr>
+              <a:t>The front today</a:t>
+            </a:r>
+            <a:endParaRPr lang="en-US" sz="1250" dirty="0"/>
+          </a:p>
+        </p:txBody>
+      </p:sp>
+      <p:sp>
+        <p:nvSpPr>
+          <p:cNvPr id="9" name="Text 6"/>
           <p:cNvSpPr txBox="1"/>
           <p:nvPr/>
         </p:nvSpPr>
         <p:spPr>
           <a:xfrm>
-            <a:off x="3017520" y="1700784"/>
-            <a:ext cx="1810512" cy="329184"/>
+            <a:off x="7818120" y="3429000"/>
+            <a:ext cx="1554480" cy="201168"/>
           </a:xfrm>
           <a:prstGeom prst="rect">
             <a:avLst/>
@@ -34207,34 +34291,34 @@
           <a:bodyPr wrap="square" lIns="0" tIns="0" rIns="0" bIns="0" rtlCol="0" anchor="ctr"/>
           <a:lstStyle/>
           <a:p>
-            <a:pPr algn="ctr" indent="0" marL="0">
-              <a:buNone/>
-            </a:pPr>
-            <a:r>
-              <a:rPr lang="en-US" sz="1250" b="1" dirty="0">
-                <a:solidFill>
-                  <a:srgbClr val="FFFFFF"/>
-                </a:solidFill>
-                <a:latin typeface="Calibri" pitchFamily="34" charset="0"/>
-                <a:ea typeface="Calibri" pitchFamily="34" charset="-122"/>
-                <a:cs typeface="Calibri" pitchFamily="34" charset="-120"/>
-              </a:rPr>
-              <a:t>Gaussian process</a:t>
-            </a:r>
-            <a:endParaRPr lang="en-US" sz="1250" dirty="0"/>
-          </a:p>
-        </p:txBody>
-      </p:sp>
-      <p:sp>
-        <p:nvSpPr>
-          <p:cNvPr id="10" name="Text 8"/>
+            <a:pPr indent="0" marL="0">
+              <a:buNone/>
+            </a:pPr>
+            <a:r>
+              <a:rPr lang="en-US" sz="950" b="1" dirty="0">
+                <a:solidFill>
+                  <a:srgbClr val="2E86AB"/>
+                </a:solidFill>
+                <a:latin typeface="Calibri" pitchFamily="34" charset="0"/>
+                <a:ea typeface="Calibri" pitchFamily="34" charset="-122"/>
+                <a:cs typeface="Calibri" pitchFamily="34" charset="-120"/>
+              </a:rPr>
+              <a:t>Fe₁₇Gd₂N₂ → Nd</a:t>
+            </a:r>
+            <a:endParaRPr lang="en-US" sz="950" dirty="0"/>
+          </a:p>
+        </p:txBody>
+      </p:sp>
+      <p:sp>
+        <p:nvSpPr>
+          <p:cNvPr id="10" name="Text 7"/>
           <p:cNvSpPr txBox="1"/>
           <p:nvPr/>
         </p:nvSpPr>
         <p:spPr>
           <a:xfrm>
-            <a:off x="3017520" y="2066544"/>
-            <a:ext cx="1810512" cy="1261872"/>
+            <a:off x="9372600" y="3429000"/>
+            <a:ext cx="1097280" cy="201168"/>
           </a:xfrm>
           <a:prstGeom prst="rect">
             <a:avLst/>
@@ -34246,68 +34330,34 @@
           <a:bodyPr wrap="square" lIns="0" tIns="0" rIns="0" bIns="0" rtlCol="0" anchor="ctr"/>
           <a:lstStyle/>
           <a:p>
-            <a:pPr algn="ctr" indent="0" marL="0">
-              <a:buNone/>
-            </a:pPr>
-            <a:r>
-              <a:rPr lang="en-US" sz="860" dirty="0">
-                <a:solidFill>
-                  <a:srgbClr val="F0F4FA"/>
-                </a:solidFill>
-                <a:latin typeface="Calibri" pitchFamily="34" charset="0"/>
-                <a:ea typeface="Calibri" pitchFamily="34" charset="-122"/>
-                <a:cs typeface="Calibri" pitchFamily="34" charset="-120"/>
-              </a:rPr>
-              <a:t>on physics descriptors (h, Fe density,</a:t>
-            </a:r>
-            <a:endParaRPr lang="en-US" sz="860" dirty="0"/>
-          </a:p>
-          <a:p>
-            <a:pPr algn="ctr" indent="0" marL="0">
-              <a:buNone/>
-            </a:pPr>
-            <a:r>
-              <a:rPr lang="en-US" sz="860" dirty="0">
-                <a:solidFill>
-                  <a:srgbClr val="F0F4FA"/>
-                </a:solidFill>
-                <a:latin typeface="Calibri" pitchFamily="34" charset="0"/>
-                <a:ea typeface="Calibri" pitchFamily="34" charset="-122"/>
-                <a:cs typeface="Calibri" pitchFamily="34" charset="-120"/>
-              </a:rPr>
-              <a:t>d_RE-TM, Z_RT, Co fraction, interstitial)</a:t>
-            </a:r>
-            <a:endParaRPr lang="en-US" sz="860" dirty="0"/>
-          </a:p>
-          <a:p>
-            <a:pPr algn="ctr" indent="0" marL="0">
-              <a:buNone/>
-            </a:pPr>
-            <a:r>
-              <a:rPr lang="en-US" sz="860" dirty="0">
-                <a:solidFill>
-                  <a:srgbClr val="F0F4FA"/>
-                </a:solidFill>
-                <a:latin typeface="Calibri" pitchFamily="34" charset="0"/>
-                <a:ea typeface="Calibri" pitchFamily="34" charset="-122"/>
-                <a:cs typeface="Calibri" pitchFamily="34" charset="-120"/>
-              </a:rPr>
-              <a:t>→ gap, Ms, E_hull with uncertainty</a:t>
-            </a:r>
-            <a:endParaRPr lang="en-US" sz="860" dirty="0"/>
-          </a:p>
-        </p:txBody>
-      </p:sp>
-      <p:sp>
-        <p:nvSpPr>
-          <p:cNvPr id="11" name="Text 9"/>
+            <a:pPr indent="0" marL="0">
+              <a:buNone/>
+            </a:pPr>
+            <a:r>
+              <a:rPr lang="en-US" sz="950" dirty="0">
+                <a:solidFill>
+                  <a:srgbClr val="1A2233"/>
+                </a:solidFill>
+                <a:latin typeface="Calibri" pitchFamily="34" charset="0"/>
+                <a:ea typeface="Calibri" pitchFamily="34" charset="-122"/>
+                <a:cs typeface="Calibri" pitchFamily="34" charset="-120"/>
+              </a:rPr>
+              <a:t>2.04 T · 82 meV</a:t>
+            </a:r>
+            <a:endParaRPr lang="en-US" sz="950" dirty="0"/>
+          </a:p>
+        </p:txBody>
+      </p:sp>
+      <p:sp>
+        <p:nvSpPr>
+          <p:cNvPr id="11" name="Text 8"/>
           <p:cNvSpPr txBox="1"/>
           <p:nvPr/>
         </p:nvSpPr>
         <p:spPr>
           <a:xfrm>
-            <a:off x="4919472" y="2286000"/>
-            <a:ext cx="274320" cy="365760"/>
+            <a:off x="7818120" y="3602736"/>
+            <a:ext cx="3566160" cy="182880"/>
           </a:xfrm>
           <a:prstGeom prst="rect">
             <a:avLst/>
@@ -34319,56 +34369,34 @@
           <a:bodyPr wrap="square" lIns="0" tIns="0" rIns="0" bIns="0" rtlCol="0" anchor="ctr"/>
           <a:lstStyle/>
           <a:p>
-            <a:pPr algn="ctr" indent="0" marL="0">
-              <a:buNone/>
-            </a:pPr>
-            <a:r>
-              <a:rPr lang="en-US" sz="1800" b="1" dirty="0">
-                <a:solidFill>
-                  <a:srgbClr val="8FA3C0"/>
-                </a:solidFill>
-                <a:latin typeface="Arial" pitchFamily="34" charset="0"/>
-                <a:ea typeface="Arial" pitchFamily="34" charset="-122"/>
-                <a:cs typeface="Arial" pitchFamily="34" charset="-120"/>
-              </a:rPr>
-              <a:t>→</a:t>
-            </a:r>
-            <a:endParaRPr lang="en-US" sz="1800" dirty="0"/>
-          </a:p>
-        </p:txBody>
-      </p:sp>
-      <p:sp>
-        <p:nvSpPr>
-          <p:cNvPr id="12" name="Shape 10"/>
-          <p:cNvSpPr/>
-          <p:nvPr/>
-        </p:nvSpPr>
-        <p:spPr>
-          <a:xfrm>
-            <a:off x="5175504" y="1600200"/>
-            <a:ext cx="2029968" cy="1783080"/>
-          </a:xfrm>
-          <a:prstGeom prst="roundRect">
-            <a:avLst>
-              <a:gd name="adj" fmla="val 4103"/>
-            </a:avLst>
-          </a:prstGeom>
-          <a:solidFill>
-            <a:srgbClr val="F2B134"/>
-          </a:solidFill>
-          <a:ln/>
-        </p:spPr>
-      </p:sp>
-      <p:sp>
-        <p:nvSpPr>
-          <p:cNvPr id="13" name="Text 11"/>
+            <a:pPr indent="0" marL="0">
+              <a:buNone/>
+            </a:pPr>
+            <a:r>
+              <a:rPr lang="en-US" sz="830" dirty="0">
+                <a:solidFill>
+                  <a:srgbClr val="5A6478"/>
+                </a:solidFill>
+                <a:latin typeface="Calibri" pitchFamily="34" charset="0"/>
+                <a:ea typeface="Calibri" pitchFamily="34" charset="-122"/>
+                <a:cs typeface="Calibri" pitchFamily="34" charset="-120"/>
+              </a:rPr>
+              <a:t>highest Ms, below the coupling floor</a:t>
+            </a:r>
+            <a:endParaRPr lang="en-US" sz="830" dirty="0"/>
+          </a:p>
+        </p:txBody>
+      </p:sp>
+      <p:sp>
+        <p:nvSpPr>
+          <p:cNvPr id="12" name="Text 9"/>
           <p:cNvSpPr txBox="1"/>
           <p:nvPr/>
         </p:nvSpPr>
         <p:spPr>
           <a:xfrm>
-            <a:off x="5285232" y="1700784"/>
-            <a:ext cx="1810512" cy="329184"/>
+            <a:off x="7818120" y="3794760"/>
+            <a:ext cx="1554480" cy="201168"/>
           </a:xfrm>
           <a:prstGeom prst="rect">
             <a:avLst/>
@@ -34380,34 +34408,34 @@
           <a:bodyPr wrap="square" lIns="0" tIns="0" rIns="0" bIns="0" rtlCol="0" anchor="ctr"/>
           <a:lstStyle/>
           <a:p>
-            <a:pPr algn="ctr" indent="0" marL="0">
-              <a:buNone/>
-            </a:pPr>
-            <a:r>
-              <a:rPr lang="en-US" sz="1250" b="1" dirty="0">
-                <a:solidFill>
-                  <a:srgbClr val="FFFFFF"/>
-                </a:solidFill>
-                <a:latin typeface="Calibri" pitchFamily="34" charset="0"/>
-                <a:ea typeface="Calibri" pitchFamily="34" charset="-122"/>
-                <a:cs typeface="Calibri" pitchFamily="34" charset="-120"/>
-              </a:rPr>
-              <a:t>Causal layer</a:t>
-            </a:r>
-            <a:endParaRPr lang="en-US" sz="1250" dirty="0"/>
-          </a:p>
-        </p:txBody>
-      </p:sp>
-      <p:sp>
-        <p:nvSpPr>
-          <p:cNvPr id="14" name="Text 12"/>
+            <a:pPr indent="0" marL="0">
+              <a:buNone/>
+            </a:pPr>
+            <a:r>
+              <a:rPr lang="en-US" sz="950" b="1" dirty="0">
+                <a:solidFill>
+                  <a:srgbClr val="2E86AB"/>
+                </a:solidFill>
+                <a:latin typeface="Calibri" pitchFamily="34" charset="0"/>
+                <a:ea typeface="Calibri" pitchFamily="34" charset="-122"/>
+                <a:cs typeface="Calibri" pitchFamily="34" charset="-120"/>
+              </a:rPr>
+              <a:t>BFe₁₄Gd₂ → Nd</a:t>
+            </a:r>
+            <a:endParaRPr lang="en-US" sz="950" dirty="0"/>
+          </a:p>
+        </p:txBody>
+      </p:sp>
+      <p:sp>
+        <p:nvSpPr>
+          <p:cNvPr id="13" name="Text 10"/>
           <p:cNvSpPr txBox="1"/>
           <p:nvPr/>
         </p:nvSpPr>
         <p:spPr>
           <a:xfrm>
-            <a:off x="5285232" y="2066544"/>
-            <a:ext cx="1810512" cy="1261872"/>
+            <a:off x="9372600" y="3794760"/>
+            <a:ext cx="1097280" cy="201168"/>
           </a:xfrm>
           <a:prstGeom prst="rect">
             <a:avLst/>
@@ -34419,68 +34447,34 @@
           <a:bodyPr wrap="square" lIns="0" tIns="0" rIns="0" bIns="0" rtlCol="0" anchor="ctr"/>
           <a:lstStyle/>
           <a:p>
-            <a:pPr algn="ctr" indent="0" marL="0">
-              <a:buNone/>
-            </a:pPr>
-            <a:r>
-              <a:rPr lang="en-US" sz="860" dirty="0">
-                <a:solidFill>
-                  <a:srgbClr val="F0F4FA"/>
-                </a:solidFill>
-                <a:latin typeface="Calibri" pitchFamily="34" charset="0"/>
-                <a:ea typeface="Calibri" pitchFamily="34" charset="-122"/>
-                <a:cs typeface="Calibri" pitchFamily="34" charset="-120"/>
-              </a:rPr>
-              <a:t>structural causal model</a:t>
-            </a:r>
-            <a:endParaRPr lang="en-US" sz="860" dirty="0"/>
-          </a:p>
-          <a:p>
-            <a:pPr algn="ctr" indent="0" marL="0">
-              <a:buNone/>
-            </a:pPr>
-            <a:r>
-              <a:rPr lang="en-US" sz="860" dirty="0">
-                <a:solidFill>
-                  <a:srgbClr val="F0F4FA"/>
-                </a:solidFill>
-                <a:latin typeface="Calibri" pitchFamily="34" charset="0"/>
-                <a:ea typeface="Calibri" pitchFamily="34" charset="-122"/>
-                <a:cs typeface="Calibri" pitchFamily="34" charset="-120"/>
-              </a:rPr>
-              <a:t>host → S₅d → gap; interventions,</a:t>
-            </a:r>
-            <a:endParaRPr lang="en-US" sz="860" dirty="0"/>
-          </a:p>
-          <a:p>
-            <a:pPr algn="ctr" indent="0" marL="0">
-              <a:buNone/>
-            </a:pPr>
-            <a:r>
-              <a:rPr lang="en-US" sz="860" dirty="0">
-                <a:solidFill>
-                  <a:srgbClr val="F0F4FA"/>
-                </a:solidFill>
-                <a:latin typeface="Calibri" pitchFamily="34" charset="0"/>
-                <a:ea typeface="Calibri" pitchFamily="34" charset="-122"/>
-                <a:cs typeface="Calibri" pitchFamily="34" charset="-120"/>
-              </a:rPr>
-              <a:t>not correlations, rank the levers</a:t>
-            </a:r>
-            <a:endParaRPr lang="en-US" sz="860" dirty="0"/>
-          </a:p>
-        </p:txBody>
-      </p:sp>
-      <p:sp>
-        <p:nvSpPr>
-          <p:cNvPr id="15" name="Text 13"/>
+            <a:pPr indent="0" marL="0">
+              <a:buNone/>
+            </a:pPr>
+            <a:r>
+              <a:rPr lang="en-US" sz="950" dirty="0">
+                <a:solidFill>
+                  <a:srgbClr val="1A2233"/>
+                </a:solidFill>
+                <a:latin typeface="Calibri" pitchFamily="34" charset="0"/>
+                <a:ea typeface="Calibri" pitchFamily="34" charset="-122"/>
+                <a:cs typeface="Calibri" pitchFamily="34" charset="-120"/>
+              </a:rPr>
+              <a:t>2.03 T · 107 meV</a:t>
+            </a:r>
+            <a:endParaRPr lang="en-US" sz="950" dirty="0"/>
+          </a:p>
+        </p:txBody>
+      </p:sp>
+      <p:sp>
+        <p:nvSpPr>
+          <p:cNvPr id="14" name="Text 11"/>
           <p:cNvSpPr txBox="1"/>
           <p:nvPr/>
         </p:nvSpPr>
         <p:spPr>
           <a:xfrm>
-            <a:off x="7187184" y="2286000"/>
-            <a:ext cx="274320" cy="365760"/>
+            <a:off x="7818120" y="3968496"/>
+            <a:ext cx="3566160" cy="182880"/>
           </a:xfrm>
           <a:prstGeom prst="rect">
             <a:avLst/>
@@ -34492,56 +34486,34 @@
           <a:bodyPr wrap="square" lIns="0" tIns="0" rIns="0" bIns="0" rtlCol="0" anchor="ctr"/>
           <a:lstStyle/>
           <a:p>
-            <a:pPr algn="ctr" indent="0" marL="0">
-              <a:buNone/>
-            </a:pPr>
-            <a:r>
-              <a:rPr lang="en-US" sz="1800" b="1" dirty="0">
-                <a:solidFill>
-                  <a:srgbClr val="8FA3C0"/>
-                </a:solidFill>
-                <a:latin typeface="Arial" pitchFamily="34" charset="0"/>
-                <a:ea typeface="Arial" pitchFamily="34" charset="-122"/>
-                <a:cs typeface="Arial" pitchFamily="34" charset="-120"/>
-              </a:rPr>
-              <a:t>→</a:t>
-            </a:r>
-            <a:endParaRPr lang="en-US" sz="1800" dirty="0"/>
-          </a:p>
-        </p:txBody>
-      </p:sp>
-      <p:sp>
-        <p:nvSpPr>
-          <p:cNvPr id="16" name="Shape 14"/>
-          <p:cNvSpPr/>
-          <p:nvPr/>
-        </p:nvSpPr>
-        <p:spPr>
-          <a:xfrm>
-            <a:off x="7443216" y="1600200"/>
-            <a:ext cx="2029968" cy="1783080"/>
-          </a:xfrm>
-          <a:prstGeom prst="roundRect">
-            <a:avLst>
-              <a:gd name="adj" fmla="val 4103"/>
-            </a:avLst>
-          </a:prstGeom>
-          <a:solidFill>
-            <a:srgbClr val="E4572E"/>
-          </a:solidFill>
-          <a:ln/>
-        </p:spPr>
-      </p:sp>
-      <p:sp>
-        <p:nvSpPr>
-          <p:cNvPr id="17" name="Text 15"/>
+            <a:pPr indent="0" marL="0">
+              <a:buNone/>
+            </a:pPr>
+            <a:r>
+              <a:rPr lang="en-US" sz="830" dirty="0">
+                <a:solidFill>
+                  <a:srgbClr val="5A6478"/>
+                </a:solidFill>
+                <a:latin typeface="Calibri" pitchFamily="34" charset="0"/>
+                <a:ea typeface="Calibri" pitchFamily="34" charset="-122"/>
+                <a:cs typeface="Calibri" pitchFamily="34" charset="-120"/>
+              </a:rPr>
+              <a:t>the Nd₂Fe₁₄B reference point</a:t>
+            </a:r>
+            <a:endParaRPr lang="en-US" sz="830" dirty="0"/>
+          </a:p>
+        </p:txBody>
+      </p:sp>
+      <p:sp>
+        <p:nvSpPr>
+          <p:cNvPr id="15" name="Text 12"/>
           <p:cNvSpPr txBox="1"/>
           <p:nvPr/>
         </p:nvSpPr>
         <p:spPr>
           <a:xfrm>
-            <a:off x="7552944" y="1700784"/>
-            <a:ext cx="1810512" cy="329184"/>
+            <a:off x="7818120" y="4160520"/>
+            <a:ext cx="1554480" cy="201168"/>
           </a:xfrm>
           <a:prstGeom prst="rect">
             <a:avLst/>
@@ -34553,34 +34525,34 @@
           <a:bodyPr wrap="square" lIns="0" tIns="0" rIns="0" bIns="0" rtlCol="0" anchor="ctr"/>
           <a:lstStyle/>
           <a:p>
-            <a:pPr algn="ctr" indent="0" marL="0">
-              <a:buNone/>
-            </a:pPr>
-            <a:r>
-              <a:rPr lang="en-US" sz="1250" b="1" dirty="0">
-                <a:solidFill>
-                  <a:srgbClr val="FFFFFF"/>
-                </a:solidFill>
-                <a:latin typeface="Calibri" pitchFamily="34" charset="0"/>
-                <a:ea typeface="Calibri" pitchFamily="34" charset="-122"/>
-                <a:cs typeface="Calibri" pitchFamily="34" charset="-120"/>
-              </a:rPr>
-              <a:t>Generative proposal</a:t>
-            </a:r>
-            <a:endParaRPr lang="en-US" sz="1250" dirty="0"/>
-          </a:p>
-        </p:txBody>
-      </p:sp>
-      <p:sp>
-        <p:nvSpPr>
-          <p:cNvPr id="18" name="Text 16"/>
+            <a:pPr indent="0" marL="0">
+              <a:buNone/>
+            </a:pPr>
+            <a:r>
+              <a:rPr lang="en-US" sz="950" b="1" dirty="0">
+                <a:solidFill>
+                  <a:srgbClr val="2E86AB"/>
+                </a:solidFill>
+                <a:latin typeface="Calibri" pitchFamily="34" charset="0"/>
+                <a:ea typeface="Calibri" pitchFamily="34" charset="-122"/>
+                <a:cs typeface="Calibri" pitchFamily="34" charset="-120"/>
+              </a:rPr>
+              <a:t>Co₂Fe₇Gd₃ → Nd</a:t>
+            </a:r>
+            <a:endParaRPr lang="en-US" sz="950" dirty="0"/>
+          </a:p>
+        </p:txBody>
+      </p:sp>
+      <p:sp>
+        <p:nvSpPr>
+          <p:cNvPr id="16" name="Text 13"/>
           <p:cNvSpPr txBox="1"/>
           <p:nvPr/>
         </p:nvSpPr>
         <p:spPr>
           <a:xfrm>
-            <a:off x="7552944" y="2066544"/>
-            <a:ext cx="1810512" cy="1261872"/>
+            <a:off x="9372600" y="4160520"/>
+            <a:ext cx="1097280" cy="201168"/>
           </a:xfrm>
           <a:prstGeom prst="rect">
             <a:avLst/>
@@ -34592,68 +34564,34 @@
           <a:bodyPr wrap="square" lIns="0" tIns="0" rIns="0" bIns="0" rtlCol="0" anchor="ctr"/>
           <a:lstStyle/>
           <a:p>
-            <a:pPr algn="ctr" indent="0" marL="0">
-              <a:buNone/>
-            </a:pPr>
-            <a:r>
-              <a:rPr lang="en-US" sz="860" dirty="0">
-                <a:solidFill>
-                  <a:srgbClr val="F0F4FA"/>
-                </a:solidFill>
-                <a:latin typeface="Calibri" pitchFamily="34" charset="0"/>
-                <a:ea typeface="Calibri" pitchFamily="34" charset="-122"/>
-                <a:cs typeface="Calibri" pitchFamily="34" charset="-120"/>
-              </a:rPr>
-              <a:t>diffusion / MatterGen conditioned on</a:t>
-            </a:r>
-            <a:endParaRPr lang="en-US" sz="860" dirty="0"/>
-          </a:p>
-          <a:p>
-            <a:pPr algn="ctr" indent="0" marL="0">
-              <a:buNone/>
-            </a:pPr>
-            <a:r>
-              <a:rPr lang="en-US" sz="860" dirty="0">
-                <a:solidFill>
-                  <a:srgbClr val="F0F4FA"/>
-                </a:solidFill>
-                <a:latin typeface="Calibri" pitchFamily="34" charset="0"/>
-                <a:ea typeface="Calibri" pitchFamily="34" charset="-122"/>
-                <a:cs typeface="Calibri" pitchFamily="34" charset="-120"/>
-              </a:rPr>
-              <a:t>dense Fe, short RE-TM, early TM;</a:t>
-            </a:r>
-            <a:endParaRPr lang="en-US" sz="860" dirty="0"/>
-          </a:p>
-          <a:p>
-            <a:pPr algn="ctr" indent="0" marL="0">
-              <a:buNone/>
-            </a:pPr>
-            <a:r>
-              <a:rPr lang="en-US" sz="860" dirty="0">
-                <a:solidFill>
-                  <a:srgbClr val="F0F4FA"/>
-                </a:solidFill>
-                <a:latin typeface="Calibri" pitchFamily="34" charset="0"/>
-                <a:ea typeface="Calibri" pitchFamily="34" charset="-122"/>
-                <a:cs typeface="Calibri" pitchFamily="34" charset="-120"/>
-              </a:rPr>
-              <a:t>MACE hull as the first filter</a:t>
-            </a:r>
-            <a:endParaRPr lang="en-US" sz="860" dirty="0"/>
-          </a:p>
-        </p:txBody>
-      </p:sp>
-      <p:sp>
-        <p:nvSpPr>
-          <p:cNvPr id="19" name="Text 17"/>
+            <a:pPr indent="0" marL="0">
+              <a:buNone/>
+            </a:pPr>
+            <a:r>
+              <a:rPr lang="en-US" sz="950" dirty="0">
+                <a:solidFill>
+                  <a:srgbClr val="1A2233"/>
+                </a:solidFill>
+                <a:latin typeface="Calibri" pitchFamily="34" charset="0"/>
+                <a:ea typeface="Calibri" pitchFamily="34" charset="-122"/>
+                <a:cs typeface="Calibri" pitchFamily="34" charset="-120"/>
+              </a:rPr>
+              <a:t>1.85 T · 110 meV</a:t>
+            </a:r>
+            <a:endParaRPr lang="en-US" sz="950" dirty="0"/>
+          </a:p>
+        </p:txBody>
+      </p:sp>
+      <p:sp>
+        <p:nvSpPr>
+          <p:cNvPr id="17" name="Text 14"/>
           <p:cNvSpPr txBox="1"/>
           <p:nvPr/>
         </p:nvSpPr>
         <p:spPr>
           <a:xfrm>
-            <a:off x="9454896" y="2286000"/>
-            <a:ext cx="274320" cy="365760"/>
+            <a:off x="7818120" y="4334256"/>
+            <a:ext cx="3566160" cy="182880"/>
           </a:xfrm>
           <a:prstGeom prst="rect">
             <a:avLst/>
@@ -34665,56 +34603,34 @@
           <a:bodyPr wrap="square" lIns="0" tIns="0" rIns="0" bIns="0" rtlCol="0" anchor="ctr"/>
           <a:lstStyle/>
           <a:p>
-            <a:pPr algn="ctr" indent="0" marL="0">
-              <a:buNone/>
-            </a:pPr>
-            <a:r>
-              <a:rPr lang="en-US" sz="1800" b="1" dirty="0">
-                <a:solidFill>
-                  <a:srgbClr val="8FA3C0"/>
-                </a:solidFill>
-                <a:latin typeface="Arial" pitchFamily="34" charset="0"/>
-                <a:ea typeface="Arial" pitchFamily="34" charset="-122"/>
-                <a:cs typeface="Arial" pitchFamily="34" charset="-120"/>
-              </a:rPr>
-              <a:t>→</a:t>
-            </a:r>
-            <a:endParaRPr lang="en-US" sz="1800" dirty="0"/>
-          </a:p>
-        </p:txBody>
-      </p:sp>
-      <p:sp>
-        <p:nvSpPr>
-          <p:cNvPr id="20" name="Shape 18"/>
-          <p:cNvSpPr/>
-          <p:nvPr/>
-        </p:nvSpPr>
-        <p:spPr>
-          <a:xfrm>
-            <a:off x="9710928" y="1600200"/>
-            <a:ext cx="2029968" cy="1783080"/>
-          </a:xfrm>
-          <a:prstGeom prst="roundRect">
-            <a:avLst>
-              <a:gd name="adj" fmla="val 4103"/>
-            </a:avLst>
-          </a:prstGeom>
-          <a:solidFill>
-            <a:srgbClr val="C6472A"/>
-          </a:solidFill>
-          <a:ln/>
-        </p:spPr>
-      </p:sp>
-      <p:sp>
-        <p:nvSpPr>
-          <p:cNvPr id="21" name="Text 19"/>
+            <a:pPr indent="0" marL="0">
+              <a:buNone/>
+            </a:pPr>
+            <a:r>
+              <a:rPr lang="en-US" sz="830" dirty="0">
+                <a:solidFill>
+                  <a:srgbClr val="5A6478"/>
+                </a:solidFill>
+                <a:latin typeface="Calibri" pitchFamily="34" charset="0"/>
+                <a:ea typeface="Calibri" pitchFamily="34" charset="-122"/>
+                <a:cs typeface="Calibri" pitchFamily="34" charset="-120"/>
+              </a:rPr>
+              <a:t>RE-rich, hull +20 meV</a:t>
+            </a:r>
+            <a:endParaRPr lang="en-US" sz="830" dirty="0"/>
+          </a:p>
+        </p:txBody>
+      </p:sp>
+      <p:sp>
+        <p:nvSpPr>
+          <p:cNvPr id="18" name="Text 15"/>
           <p:cNvSpPr txBox="1"/>
           <p:nvPr/>
         </p:nvSpPr>
         <p:spPr>
           <a:xfrm>
-            <a:off x="9820656" y="1700784"/>
-            <a:ext cx="1810512" cy="329184"/>
+            <a:off x="7818120" y="4526280"/>
+            <a:ext cx="1554480" cy="201168"/>
           </a:xfrm>
           <a:prstGeom prst="rect">
             <a:avLst/>
@@ -34726,34 +34642,34 @@
           <a:bodyPr wrap="square" lIns="0" tIns="0" rIns="0" bIns="0" rtlCol="0" anchor="ctr"/>
           <a:lstStyle/>
           <a:p>
-            <a:pPr algn="ctr" indent="0" marL="0">
-              <a:buNone/>
-            </a:pPr>
-            <a:r>
-              <a:rPr lang="en-US" sz="1250" b="1" dirty="0">
-                <a:solidFill>
-                  <a:srgbClr val="FFFFFF"/>
-                </a:solidFill>
-                <a:latin typeface="Calibri" pitchFamily="34" charset="0"/>
-                <a:ea typeface="Calibri" pitchFamily="34" charset="-122"/>
-                <a:cs typeface="Calibri" pitchFamily="34" charset="-120"/>
-              </a:rPr>
-              <a:t>One run per cell</a:t>
-            </a:r>
-            <a:endParaRPr lang="en-US" sz="1250" dirty="0"/>
-          </a:p>
-        </p:txBody>
-      </p:sp>
-      <p:sp>
-        <p:nvSpPr>
-          <p:cNvPr id="22" name="Text 20"/>
+            <a:pPr indent="0" marL="0">
+              <a:buNone/>
+            </a:pPr>
+            <a:r>
+              <a:rPr lang="en-US" sz="950" b="1" dirty="0">
+                <a:solidFill>
+                  <a:srgbClr val="2E86AB"/>
+                </a:solidFill>
+                <a:latin typeface="Calibri" pitchFamily="34" charset="0"/>
+                <a:ea typeface="Calibri" pitchFamily="34" charset="-122"/>
+                <a:cs typeface="Calibri" pitchFamily="34" charset="-120"/>
+              </a:rPr>
+              <a:t>GdFe₂ → Nd</a:t>
+            </a:r>
+            <a:endParaRPr lang="en-US" sz="950" dirty="0"/>
+          </a:p>
+        </p:txBody>
+      </p:sp>
+      <p:sp>
+        <p:nvSpPr>
+          <p:cNvPr id="19" name="Text 16"/>
           <p:cNvSpPr txBox="1"/>
           <p:nvPr/>
         </p:nvSpPr>
         <p:spPr>
           <a:xfrm>
-            <a:off x="9820656" y="2066544"/>
-            <a:ext cx="1810512" cy="1261872"/>
+            <a:off x="9372600" y="4526280"/>
+            <a:ext cx="1097280" cy="201168"/>
           </a:xfrm>
           <a:prstGeom prst="rect">
             <a:avLst/>
@@ -34765,138 +34681,34 @@
           <a:bodyPr wrap="square" lIns="0" tIns="0" rIns="0" bIns="0" rtlCol="0" anchor="ctr"/>
           <a:lstStyle/>
           <a:p>
-            <a:pPr algn="ctr" indent="0" marL="0">
-              <a:buNone/>
-            </a:pPr>
-            <a:r>
-              <a:rPr lang="en-US" sz="860" dirty="0">
-                <a:solidFill>
-                  <a:srgbClr val="F0F4FA"/>
-                </a:solidFill>
-                <a:latin typeface="Calibri" pitchFamily="34" charset="0"/>
-                <a:ea typeface="Calibri" pitchFamily="34" charset="-122"/>
-                <a:cs typeface="Calibri" pitchFamily="34" charset="-120"/>
-              </a:rPr>
-              <a:t>f-in-core relaxation gives</a:t>
-            </a:r>
-            <a:endParaRPr lang="en-US" sz="860" dirty="0"/>
-          </a:p>
-          <a:p>
-            <a:pPr algn="ctr" indent="0" marL="0">
-              <a:buNone/>
-            </a:pPr>
-            <a:r>
-              <a:rPr lang="en-US" sz="860" dirty="0">
-                <a:solidFill>
-                  <a:srgbClr val="F0F4FA"/>
-                </a:solidFill>
-                <a:latin typeface="Calibri" pitchFamily="34" charset="0"/>
-                <a:ea typeface="Calibri" pitchFamily="34" charset="-122"/>
-                <a:cs typeface="Calibri" pitchFamily="34" charset="-120"/>
-              </a:rPr>
-              <a:t>Ms, h → gap, T*; results</a:t>
-            </a:r>
-            <a:endParaRPr lang="en-US" sz="860" dirty="0"/>
-          </a:p>
-          <a:p>
-            <a:pPr algn="ctr" indent="0" marL="0">
-              <a:buNone/>
-            </a:pPr>
-            <a:r>
-              <a:rPr lang="en-US" sz="860" dirty="0">
-                <a:solidFill>
-                  <a:srgbClr val="F0F4FA"/>
-                </a:solidFill>
-                <a:latin typeface="Calibri" pitchFamily="34" charset="0"/>
-                <a:ea typeface="Calibri" pitchFamily="34" charset="-122"/>
-                <a:cs typeface="Calibri" pitchFamily="34" charset="-120"/>
-              </a:rPr>
-              <a:t>re-train every layer</a:t>
-            </a:r>
-            <a:endParaRPr lang="en-US" sz="860" dirty="0"/>
-          </a:p>
-        </p:txBody>
-      </p:sp>
-      <p:sp>
-        <p:nvSpPr>
-          <p:cNvPr id="23" name="Shape 21"/>
-          <p:cNvSpPr/>
-          <p:nvPr/>
-        </p:nvSpPr>
-        <p:spPr>
-          <a:xfrm>
-            <a:off x="10725912" y="3383280"/>
-            <a:ext cx="0" cy="457200"/>
-          </a:xfrm>
-          <a:prstGeom prst="line">
-            <a:avLst/>
-          </a:prstGeom>
-          <a:noFill/>
-          <a:ln w="19050">
-            <a:solidFill>
-              <a:srgbClr val="8FA3C0"/>
-            </a:solidFill>
-            <a:prstDash val="solid"/>
-          </a:ln>
-        </p:spPr>
-      </p:sp>
-      <p:sp>
-        <p:nvSpPr>
-          <p:cNvPr id="24" name="Shape 22"/>
-          <p:cNvSpPr/>
-          <p:nvPr/>
-        </p:nvSpPr>
-        <p:spPr>
-          <a:xfrm>
-            <a:off x="1655064" y="3840480"/>
-            <a:ext cx="9070848" cy="0"/>
-          </a:xfrm>
-          <a:prstGeom prst="line">
-            <a:avLst/>
-          </a:prstGeom>
-          <a:noFill/>
-          <a:ln w="19050">
-            <a:solidFill>
-              <a:srgbClr val="8FA3C0"/>
-            </a:solidFill>
-            <a:prstDash val="solid"/>
-          </a:ln>
-        </p:spPr>
-      </p:sp>
-      <p:sp>
-        <p:nvSpPr>
-          <p:cNvPr id="25" name="Shape 23"/>
-          <p:cNvSpPr/>
-          <p:nvPr/>
-        </p:nvSpPr>
-        <p:spPr>
-          <a:xfrm>
-            <a:off x="1655064" y="3383280"/>
-            <a:ext cx="0" cy="457200"/>
-          </a:xfrm>
-          <a:prstGeom prst="line">
-            <a:avLst/>
-          </a:prstGeom>
-          <a:noFill/>
-          <a:ln w="19050">
-            <a:solidFill>
-              <a:srgbClr val="8FA3C0"/>
-            </a:solidFill>
-            <a:prstDash val="solid"/>
-            <a:headEnd type="triangle"/>
-          </a:ln>
-        </p:spPr>
-      </p:sp>
-      <p:sp>
-        <p:nvSpPr>
-          <p:cNvPr id="26" name="Text 24"/>
+            <a:pPr indent="0" marL="0">
+              <a:buNone/>
+            </a:pPr>
+            <a:r>
+              <a:rPr lang="en-US" sz="950" dirty="0">
+                <a:solidFill>
+                  <a:srgbClr val="1A2233"/>
+                </a:solidFill>
+                <a:latin typeface="Calibri" pitchFamily="34" charset="0"/>
+                <a:ea typeface="Calibri" pitchFamily="34" charset="-122"/>
+                <a:cs typeface="Calibri" pitchFamily="34" charset="-120"/>
+              </a:rPr>
+              <a:t>1.81 T · 123 meV</a:t>
+            </a:r>
+            <a:endParaRPr lang="en-US" sz="950" dirty="0"/>
+          </a:p>
+        </p:txBody>
+      </p:sp>
+      <p:sp>
+        <p:nvSpPr>
+          <p:cNvPr id="20" name="Text 17"/>
           <p:cNvSpPr txBox="1"/>
           <p:nvPr/>
         </p:nvSpPr>
         <p:spPr>
           <a:xfrm>
-            <a:off x="2468880" y="3877056"/>
-            <a:ext cx="7315200" cy="274320"/>
+            <a:off x="7818120" y="4700016"/>
+            <a:ext cx="3566160" cy="182880"/>
           </a:xfrm>
           <a:prstGeom prst="rect">
             <a:avLst/>
@@ -34908,56 +34720,34 @@
           <a:bodyPr wrap="square" lIns="0" tIns="0" rIns="0" bIns="0" rtlCol="0" anchor="ctr"/>
           <a:lstStyle/>
           <a:p>
-            <a:pPr algn="ctr" indent="0" marL="0">
-              <a:buNone/>
-            </a:pPr>
-            <a:r>
-              <a:rPr lang="en-US" sz="1000" i="1" dirty="0">
-                <a:solidFill>
-                  <a:srgbClr val="8FA3C0"/>
-                </a:solidFill>
-                <a:latin typeface="Calibri" pitchFamily="34" charset="0"/>
-                <a:ea typeface="Calibri" pitchFamily="34" charset="-122"/>
-                <a:cs typeface="Calibri" pitchFamily="34" charset="-120"/>
-              </a:rPr>
-              <a:t>every batch is a designed experiment: it must move the GP posterior or test a causal edge, not just add points</a:t>
-            </a:r>
-            <a:endParaRPr lang="en-US" sz="1000" dirty="0"/>
-          </a:p>
-        </p:txBody>
-      </p:sp>
-      <p:sp>
-        <p:nvSpPr>
-          <p:cNvPr id="27" name="Shape 25"/>
-          <p:cNvSpPr/>
-          <p:nvPr/>
-        </p:nvSpPr>
-        <p:spPr>
-          <a:xfrm>
-            <a:off x="640080" y="4297680"/>
-            <a:ext cx="5577840" cy="1920240"/>
-          </a:xfrm>
-          <a:prstGeom prst="roundRect">
-            <a:avLst>
-              <a:gd name="adj" fmla="val 2857"/>
-            </a:avLst>
-          </a:prstGeom>
-          <a:solidFill>
-            <a:srgbClr val="1B2A4A"/>
-          </a:solidFill>
-          <a:ln/>
-        </p:spPr>
-      </p:sp>
-      <p:sp>
-        <p:nvSpPr>
-          <p:cNvPr id="28" name="Text 26"/>
+            <a:pPr indent="0" marL="0">
+              <a:buNone/>
+            </a:pPr>
+            <a:r>
+              <a:rPr lang="en-US" sz="830" dirty="0">
+                <a:solidFill>
+                  <a:srgbClr val="5A6478"/>
+                </a:solidFill>
+                <a:latin typeface="Calibri" pitchFamily="34" charset="0"/>
+                <a:ea typeface="Calibri" pitchFamily="34" charset="-122"/>
+                <a:cs typeface="Calibri" pitchFamily="34" charset="-120"/>
+              </a:rPr>
+              <a:t>Laves, RE-rich</a:t>
+            </a:r>
+            <a:endParaRPr lang="en-US" sz="830" dirty="0"/>
+          </a:p>
+        </p:txBody>
+      </p:sp>
+      <p:sp>
+        <p:nvSpPr>
+          <p:cNvPr id="21" name="Text 18"/>
           <p:cNvSpPr txBox="1"/>
           <p:nvPr/>
         </p:nvSpPr>
         <p:spPr>
           <a:xfrm>
-            <a:off x="822960" y="4389120"/>
-            <a:ext cx="5212080" cy="256032"/>
+            <a:off x="7818120" y="4892040"/>
+            <a:ext cx="1554480" cy="201168"/>
           </a:xfrm>
           <a:prstGeom prst="rect">
             <a:avLst/>
@@ -34973,52 +34763,30 @@
               <a:buNone/>
             </a:pPr>
             <a:r>
-              <a:rPr lang="en-US" sz="1150" b="1" dirty="0">
-                <a:solidFill>
-                  <a:srgbClr val="F2B134"/>
-                </a:solidFill>
-                <a:latin typeface="Calibri" pitchFamily="34" charset="0"/>
-                <a:ea typeface="Calibri" pitchFamily="34" charset="-122"/>
-                <a:cs typeface="Calibri" pitchFamily="34" charset="-120"/>
-              </a:rPr>
-              <a:t>The causal model the data support</a:t>
-            </a:r>
-            <a:endParaRPr lang="en-US" sz="1150" dirty="0"/>
-          </a:p>
-        </p:txBody>
-      </p:sp>
-      <p:sp>
-        <p:nvSpPr>
-          <p:cNvPr id="29" name="Shape 27"/>
-          <p:cNvSpPr/>
-          <p:nvPr/>
-        </p:nvSpPr>
-        <p:spPr>
-          <a:xfrm>
-            <a:off x="868680" y="4800600"/>
-            <a:ext cx="1417320" cy="530352"/>
-          </a:xfrm>
-          <a:prstGeom prst="roundRect">
-            <a:avLst>
-              <a:gd name="adj" fmla="val 13793"/>
-            </a:avLst>
-          </a:prstGeom>
-          <a:solidFill>
-            <a:srgbClr val="2E86AB"/>
-          </a:solidFill>
-          <a:ln/>
-        </p:spPr>
-      </p:sp>
-      <p:sp>
-        <p:nvSpPr>
-          <p:cNvPr id="30" name="Text 28"/>
+              <a:rPr lang="en-US" sz="950" b="1" dirty="0">
+                <a:solidFill>
+                  <a:srgbClr val="2E86AB"/>
+                </a:solidFill>
+                <a:latin typeface="Calibri" pitchFamily="34" charset="0"/>
+                <a:ea typeface="Calibri" pitchFamily="34" charset="-122"/>
+                <a:cs typeface="Calibri" pitchFamily="34" charset="-120"/>
+              </a:rPr>
+              <a:t>Co₁₉Fe₄Gd₆ → Nd</a:t>
+            </a:r>
+            <a:endParaRPr lang="en-US" sz="950" dirty="0"/>
+          </a:p>
+        </p:txBody>
+      </p:sp>
+      <p:sp>
+        <p:nvSpPr>
+          <p:cNvPr id="22" name="Text 19"/>
           <p:cNvSpPr txBox="1"/>
           <p:nvPr/>
         </p:nvSpPr>
         <p:spPr>
           <a:xfrm>
-            <a:off x="868680" y="4800600"/>
-            <a:ext cx="1417320" cy="530352"/>
+            <a:off x="9372600" y="4892040"/>
+            <a:ext cx="1097280" cy="201168"/>
           </a:xfrm>
           <a:prstGeom prst="rect">
             <a:avLst/>
@@ -35030,73 +34798,34 @@
           <a:bodyPr wrap="square" lIns="0" tIns="0" rIns="0" bIns="0" rtlCol="0" anchor="ctr"/>
           <a:lstStyle/>
           <a:p>
-            <a:pPr algn="ctr" indent="0" marL="0">
-              <a:buNone/>
-            </a:pPr>
-            <a:r>
-              <a:rPr lang="en-US" sz="800" b="1" dirty="0">
-                <a:solidFill>
-                  <a:srgbClr val="FFFFFF"/>
-                </a:solidFill>
-                <a:latin typeface="Calibri" pitchFamily="34" charset="0"/>
-                <a:ea typeface="Calibri" pitchFamily="34" charset="-122"/>
-                <a:cs typeface="Calibri" pitchFamily="34" charset="-120"/>
-              </a:rPr>
-              <a:t>RE-TM distance</a:t>
-            </a:r>
-            <a:endParaRPr lang="en-US" sz="800" dirty="0"/>
-          </a:p>
-          <a:p>
-            <a:pPr algn="ctr" indent="0" marL="0">
-              <a:buNone/>
-            </a:pPr>
-            <a:r>
-              <a:rPr lang="en-US" sz="800" b="1" dirty="0">
-                <a:solidFill>
-                  <a:srgbClr val="FFFFFF"/>
-                </a:solidFill>
-                <a:latin typeface="Calibri" pitchFamily="34" charset="0"/>
-                <a:ea typeface="Calibri" pitchFamily="34" charset="-122"/>
-                <a:cs typeface="Calibri" pitchFamily="34" charset="-120"/>
-              </a:rPr>
-              <a:t>coordination</a:t>
-            </a:r>
-            <a:endParaRPr lang="en-US" sz="800" dirty="0"/>
-          </a:p>
-        </p:txBody>
-      </p:sp>
-      <p:sp>
-        <p:nvSpPr>
-          <p:cNvPr id="31" name="Shape 29"/>
-          <p:cNvSpPr/>
-          <p:nvPr/>
-        </p:nvSpPr>
-        <p:spPr>
-          <a:xfrm>
-            <a:off x="868680" y="5440680"/>
-            <a:ext cx="1417320" cy="530352"/>
-          </a:xfrm>
-          <a:prstGeom prst="roundRect">
-            <a:avLst>
-              <a:gd name="adj" fmla="val 13793"/>
-            </a:avLst>
-          </a:prstGeom>
-          <a:solidFill>
-            <a:srgbClr val="2E86AB"/>
-          </a:solidFill>
-          <a:ln/>
-        </p:spPr>
-      </p:sp>
-      <p:sp>
-        <p:nvSpPr>
-          <p:cNvPr id="32" name="Text 30"/>
+            <a:pPr indent="0" marL="0">
+              <a:buNone/>
+            </a:pPr>
+            <a:r>
+              <a:rPr lang="en-US" sz="950" dirty="0">
+                <a:solidFill>
+                  <a:srgbClr val="1A2233"/>
+                </a:solidFill>
+                <a:latin typeface="Calibri" pitchFamily="34" charset="0"/>
+                <a:ea typeface="Calibri" pitchFamily="34" charset="-122"/>
+                <a:cs typeface="Calibri" pitchFamily="34" charset="-120"/>
+              </a:rPr>
+              <a:t>1.59 T · 130 meV</a:t>
+            </a:r>
+            <a:endParaRPr lang="en-US" sz="950" dirty="0"/>
+          </a:p>
+        </p:txBody>
+      </p:sp>
+      <p:sp>
+        <p:nvSpPr>
+          <p:cNvPr id="23" name="Text 20"/>
           <p:cNvSpPr txBox="1"/>
           <p:nvPr/>
         </p:nvSpPr>
         <p:spPr>
           <a:xfrm>
-            <a:off x="868680" y="5440680"/>
-            <a:ext cx="1417320" cy="530352"/>
+            <a:off x="7818120" y="5065776"/>
+            <a:ext cx="3566160" cy="182880"/>
           </a:xfrm>
           <a:prstGeom prst="rect">
             <a:avLst/>
@@ -35108,73 +34837,34 @@
           <a:bodyPr wrap="square" lIns="0" tIns="0" rIns="0" bIns="0" rtlCol="0" anchor="ctr"/>
           <a:lstStyle/>
           <a:p>
-            <a:pPr algn="ctr" indent="0" marL="0">
-              <a:buNone/>
-            </a:pPr>
-            <a:r>
-              <a:rPr lang="en-US" sz="800" b="1" dirty="0">
-                <a:solidFill>
-                  <a:srgbClr val="FFFFFF"/>
-                </a:solidFill>
-                <a:latin typeface="Calibri" pitchFamily="34" charset="0"/>
-                <a:ea typeface="Calibri" pitchFamily="34" charset="-122"/>
-                <a:cs typeface="Calibri" pitchFamily="34" charset="-120"/>
-              </a:rPr>
-              <a:t>Fe / Co mix</a:t>
-            </a:r>
-            <a:endParaRPr lang="en-US" sz="800" dirty="0"/>
-          </a:p>
-          <a:p>
-            <a:pPr algn="ctr" indent="0" marL="0">
-              <a:buNone/>
-            </a:pPr>
-            <a:r>
-              <a:rPr lang="en-US" sz="800" b="1" dirty="0">
-                <a:solidFill>
-                  <a:srgbClr val="FFFFFF"/>
-                </a:solidFill>
-                <a:latin typeface="Calibri" pitchFamily="34" charset="0"/>
-                <a:ea typeface="Calibri" pitchFamily="34" charset="-122"/>
-                <a:cs typeface="Calibri" pitchFamily="34" charset="-120"/>
-              </a:rPr>
-              <a:t>interstitial site</a:t>
-            </a:r>
-            <a:endParaRPr lang="en-US" sz="800" dirty="0"/>
-          </a:p>
-        </p:txBody>
-      </p:sp>
-      <p:sp>
-        <p:nvSpPr>
-          <p:cNvPr id="33" name="Shape 31"/>
-          <p:cNvSpPr/>
-          <p:nvPr/>
-        </p:nvSpPr>
-        <p:spPr>
-          <a:xfrm>
-            <a:off x="2788920" y="5120640"/>
-            <a:ext cx="1417320" cy="530352"/>
-          </a:xfrm>
-          <a:prstGeom prst="roundRect">
-            <a:avLst>
-              <a:gd name="adj" fmla="val 13793"/>
-            </a:avLst>
-          </a:prstGeom>
-          <a:solidFill>
-            <a:srgbClr val="F2B134"/>
-          </a:solidFill>
-          <a:ln/>
-        </p:spPr>
-      </p:sp>
-      <p:sp>
-        <p:nvSpPr>
-          <p:cNvPr id="34" name="Text 32"/>
+            <a:pPr indent="0" marL="0">
+              <a:buNone/>
+            </a:pPr>
+            <a:r>
+              <a:rPr lang="en-US" sz="830" dirty="0">
+                <a:solidFill>
+                  <a:srgbClr val="5A6478"/>
+                </a:solidFill>
+                <a:latin typeface="Calibri" pitchFamily="34" charset="0"/>
+                <a:ea typeface="Calibri" pitchFamily="34" charset="-122"/>
+                <a:cs typeface="Calibri" pitchFamily="34" charset="-120"/>
+              </a:rPr>
+              <a:t>strongest coupling at &gt;1.5 T</a:t>
+            </a:r>
+            <a:endParaRPr lang="en-US" sz="830" dirty="0"/>
+          </a:p>
+        </p:txBody>
+      </p:sp>
+      <p:sp>
+        <p:nvSpPr>
+          <p:cNvPr id="24" name="Text 21"/>
           <p:cNvSpPr txBox="1"/>
           <p:nvPr/>
         </p:nvSpPr>
         <p:spPr>
           <a:xfrm>
-            <a:off x="2788920" y="5120640"/>
-            <a:ext cx="1417320" cy="530352"/>
+            <a:off x="7818120" y="5257800"/>
+            <a:ext cx="1554480" cy="201168"/>
           </a:xfrm>
           <a:prstGeom prst="rect">
             <a:avLst/>
@@ -35186,73 +34876,34 @@
           <a:bodyPr wrap="square" lIns="0" tIns="0" rIns="0" bIns="0" rtlCol="0" anchor="ctr"/>
           <a:lstStyle/>
           <a:p>
-            <a:pPr algn="ctr" indent="0" marL="0">
-              <a:buNone/>
-            </a:pPr>
-            <a:r>
-              <a:rPr lang="en-US" sz="800" b="1" dirty="0">
-                <a:solidFill>
-                  <a:srgbClr val="FFFFFF"/>
-                </a:solidFill>
-                <a:latin typeface="Calibri" pitchFamily="34" charset="0"/>
-                <a:ea typeface="Calibri" pitchFamily="34" charset="-122"/>
-                <a:cs typeface="Calibri" pitchFamily="34" charset="-120"/>
-              </a:rPr>
-              <a:t>S₅d on the RE</a:t>
-            </a:r>
-            <a:endParaRPr lang="en-US" sz="800" dirty="0"/>
-          </a:p>
-          <a:p>
-            <a:pPr algn="ctr" indent="0" marL="0">
-              <a:buNone/>
-            </a:pPr>
-            <a:r>
-              <a:rPr lang="en-US" sz="800" b="1" dirty="0">
-                <a:solidFill>
-                  <a:srgbClr val="FFFFFF"/>
-                </a:solidFill>
-                <a:latin typeface="Calibri" pitchFamily="34" charset="0"/>
-                <a:ea typeface="Calibri" pitchFamily="34" charset="-122"/>
-                <a:cs typeface="Calibri" pitchFamily="34" charset="-120"/>
-              </a:rPr>
-              <a:t>(h)</a:t>
-            </a:r>
-            <a:endParaRPr lang="en-US" sz="800" dirty="0"/>
-          </a:p>
-        </p:txBody>
-      </p:sp>
-      <p:sp>
-        <p:nvSpPr>
-          <p:cNvPr id="35" name="Shape 33"/>
-          <p:cNvSpPr/>
-          <p:nvPr/>
-        </p:nvSpPr>
-        <p:spPr>
-          <a:xfrm>
-            <a:off x="4572000" y="4800600"/>
-            <a:ext cx="1417320" cy="530352"/>
-          </a:xfrm>
-          <a:prstGeom prst="roundRect">
-            <a:avLst>
-              <a:gd name="adj" fmla="val 13793"/>
-            </a:avLst>
-          </a:prstGeom>
-          <a:solidFill>
-            <a:srgbClr val="E4572E"/>
-          </a:solidFill>
-          <a:ln/>
-        </p:spPr>
-      </p:sp>
-      <p:sp>
-        <p:nvSpPr>
-          <p:cNvPr id="36" name="Text 34"/>
+            <a:pPr indent="0" marL="0">
+              <a:buNone/>
+            </a:pPr>
+            <a:r>
+              <a:rPr lang="en-US" sz="950" b="1" dirty="0">
+                <a:solidFill>
+                  <a:srgbClr val="2E86AB"/>
+                </a:solidFill>
+                <a:latin typeface="Calibri" pitchFamily="34" charset="0"/>
+                <a:ea typeface="Calibri" pitchFamily="34" charset="-122"/>
+                <a:cs typeface="Calibri" pitchFamily="34" charset="-120"/>
+              </a:rPr>
+              <a:t>CFe₁₇Gd₂ → Nd</a:t>
+            </a:r>
+            <a:endParaRPr lang="en-US" sz="950" dirty="0"/>
+          </a:p>
+        </p:txBody>
+      </p:sp>
+      <p:sp>
+        <p:nvSpPr>
+          <p:cNvPr id="25" name="Text 22"/>
           <p:cNvSpPr txBox="1"/>
           <p:nvPr/>
         </p:nvSpPr>
         <p:spPr>
           <a:xfrm>
-            <a:off x="4572000" y="4800600"/>
-            <a:ext cx="1417320" cy="530352"/>
+            <a:off x="9372600" y="5257800"/>
+            <a:ext cx="1097280" cy="201168"/>
           </a:xfrm>
           <a:prstGeom prst="rect">
             <a:avLst/>
@@ -35264,73 +34915,34 @@
           <a:bodyPr wrap="square" lIns="0" tIns="0" rIns="0" bIns="0" rtlCol="0" anchor="ctr"/>
           <a:lstStyle/>
           <a:p>
-            <a:pPr algn="ctr" indent="0" marL="0">
-              <a:buNone/>
-            </a:pPr>
-            <a:r>
-              <a:rPr lang="en-US" sz="800" b="1" dirty="0">
-                <a:solidFill>
-                  <a:srgbClr val="FFFFFF"/>
-                </a:solidFill>
-                <a:latin typeface="Calibri" pitchFamily="34" charset="0"/>
-                <a:ea typeface="Calibri" pitchFamily="34" charset="-122"/>
-                <a:cs typeface="Calibri" pitchFamily="34" charset="-120"/>
-              </a:rPr>
-              <a:t>RE-TM gap</a:t>
-            </a:r>
-            <a:endParaRPr lang="en-US" sz="800" dirty="0"/>
-          </a:p>
-          <a:p>
-            <a:pPr algn="ctr" indent="0" marL="0">
-              <a:buNone/>
-            </a:pPr>
-            <a:r>
-              <a:rPr lang="en-US" sz="800" b="1" dirty="0">
-                <a:solidFill>
-                  <a:srgbClr val="FFFFFF"/>
-                </a:solidFill>
-                <a:latin typeface="Calibri" pitchFamily="34" charset="0"/>
-                <a:ea typeface="Calibri" pitchFamily="34" charset="-122"/>
-                <a:cs typeface="Calibri" pitchFamily="34" charset="-120"/>
-              </a:rPr>
-              <a:t>T*, anisotropy lock</a:t>
-            </a:r>
-            <a:endParaRPr lang="en-US" sz="800" dirty="0"/>
-          </a:p>
-        </p:txBody>
-      </p:sp>
-      <p:sp>
-        <p:nvSpPr>
-          <p:cNvPr id="37" name="Shape 35"/>
-          <p:cNvSpPr/>
-          <p:nvPr/>
-        </p:nvSpPr>
-        <p:spPr>
-          <a:xfrm>
-            <a:off x="4572000" y="5440680"/>
-            <a:ext cx="1417320" cy="530352"/>
-          </a:xfrm>
-          <a:prstGeom prst="roundRect">
-            <a:avLst>
-              <a:gd name="adj" fmla="val 13793"/>
-            </a:avLst>
-          </a:prstGeom>
-          <a:solidFill>
-            <a:srgbClr val="E4572E"/>
-          </a:solidFill>
-          <a:ln/>
-        </p:spPr>
-      </p:sp>
-      <p:sp>
-        <p:nvSpPr>
-          <p:cNvPr id="38" name="Text 36"/>
+            <a:pPr indent="0" marL="0">
+              <a:buNone/>
+            </a:pPr>
+            <a:r>
+              <a:rPr lang="en-US" sz="950" dirty="0">
+                <a:solidFill>
+                  <a:srgbClr val="1A2233"/>
+                </a:solidFill>
+                <a:latin typeface="Calibri" pitchFamily="34" charset="0"/>
+                <a:ea typeface="Calibri" pitchFamily="34" charset="-122"/>
+                <a:cs typeface="Calibri" pitchFamily="34" charset="-120"/>
+              </a:rPr>
+              <a:t>1.35 T · 133 meV</a:t>
+            </a:r>
+            <a:endParaRPr lang="en-US" sz="950" dirty="0"/>
+          </a:p>
+        </p:txBody>
+      </p:sp>
+      <p:sp>
+        <p:nvSpPr>
+          <p:cNvPr id="26" name="Text 23"/>
           <p:cNvSpPr txBox="1"/>
           <p:nvPr/>
         </p:nvSpPr>
         <p:spPr>
           <a:xfrm>
-            <a:off x="4572000" y="5440680"/>
-            <a:ext cx="1417320" cy="530352"/>
+            <a:off x="7818120" y="5431536"/>
+            <a:ext cx="3566160" cy="182880"/>
           </a:xfrm>
           <a:prstGeom prst="rect">
             <a:avLst/>
@@ -35342,147 +34954,34 @@
           <a:bodyPr wrap="square" lIns="0" tIns="0" rIns="0" bIns="0" rtlCol="0" anchor="ctr"/>
           <a:lstStyle/>
           <a:p>
-            <a:pPr algn="ctr" indent="0" marL="0">
-              <a:buNone/>
-            </a:pPr>
-            <a:r>
-              <a:rPr lang="en-US" sz="800" b="1" dirty="0">
-                <a:solidFill>
-                  <a:srgbClr val="FFFFFF"/>
-                </a:solidFill>
-                <a:latin typeface="Calibri" pitchFamily="34" charset="0"/>
-                <a:ea typeface="Calibri" pitchFamily="34" charset="-122"/>
-                <a:cs typeface="Calibri" pitchFamily="34" charset="-120"/>
-              </a:rPr>
-              <a:t>Ms</a:t>
-            </a:r>
-            <a:endParaRPr lang="en-US" sz="800" dirty="0"/>
-          </a:p>
-          <a:p>
-            <a:pPr algn="ctr" indent="0" marL="0">
-              <a:buNone/>
-            </a:pPr>
-            <a:r>
-              <a:rPr lang="en-US" sz="800" b="1" dirty="0">
-                <a:solidFill>
-                  <a:srgbClr val="FFFFFF"/>
-                </a:solidFill>
-                <a:latin typeface="Calibri" pitchFamily="34" charset="0"/>
-                <a:ea typeface="Calibri" pitchFamily="34" charset="-122"/>
-                <a:cs typeface="Calibri" pitchFamily="34" charset="-120"/>
-              </a:rPr>
-              <a:t>(Fe density + RE)</a:t>
-            </a:r>
-            <a:endParaRPr lang="en-US" sz="800" dirty="0"/>
-          </a:p>
-        </p:txBody>
-      </p:sp>
-      <p:sp>
-        <p:nvSpPr>
-          <p:cNvPr id="39" name="Shape 37"/>
-          <p:cNvSpPr/>
-          <p:nvPr/>
-        </p:nvSpPr>
-        <p:spPr>
-          <a:xfrm>
-            <a:off x="2286000" y="5065776"/>
-            <a:ext cx="502920" cy="219456"/>
-          </a:xfrm>
-          <a:prstGeom prst="line">
-            <a:avLst/>
-          </a:prstGeom>
-          <a:noFill/>
-          <a:ln w="17780">
-            <a:solidFill>
-              <a:srgbClr val="C6D2E4"/>
-            </a:solidFill>
-            <a:prstDash val="solid"/>
-            <a:tailEnd type="triangle"/>
-          </a:ln>
-        </p:spPr>
-      </p:sp>
-      <p:sp>
-        <p:nvSpPr>
-          <p:cNvPr id="40" name="Shape 38"/>
-          <p:cNvSpPr/>
-          <p:nvPr/>
-        </p:nvSpPr>
-        <p:spPr>
-          <a:xfrm>
-            <a:off x="2286000" y="5705856"/>
-            <a:ext cx="502920" cy="-219456"/>
-          </a:xfrm>
-          <a:prstGeom prst="line">
-            <a:avLst/>
-          </a:prstGeom>
-          <a:noFill/>
-          <a:ln w="17780">
-            <a:solidFill>
-              <a:srgbClr val="C6D2E4"/>
-            </a:solidFill>
-            <a:prstDash val="solid"/>
-            <a:tailEnd type="triangle"/>
-          </a:ln>
-        </p:spPr>
-      </p:sp>
-      <p:sp>
-        <p:nvSpPr>
-          <p:cNvPr id="41" name="Shape 39"/>
-          <p:cNvSpPr/>
-          <p:nvPr/>
-        </p:nvSpPr>
-        <p:spPr>
-          <a:xfrm>
-            <a:off x="4206240" y="5285232"/>
-            <a:ext cx="365760" cy="-201168"/>
-          </a:xfrm>
-          <a:prstGeom prst="line">
-            <a:avLst/>
-          </a:prstGeom>
-          <a:noFill/>
-          <a:ln w="17780">
-            <a:solidFill>
-              <a:srgbClr val="C6D2E4"/>
-            </a:solidFill>
-            <a:prstDash val="solid"/>
-            <a:tailEnd type="triangle"/>
-          </a:ln>
-        </p:spPr>
-      </p:sp>
-      <p:sp>
-        <p:nvSpPr>
-          <p:cNvPr id="42" name="Shape 40"/>
-          <p:cNvSpPr/>
-          <p:nvPr/>
-        </p:nvSpPr>
-        <p:spPr>
-          <a:xfrm>
-            <a:off x="2286000" y="5760720"/>
-            <a:ext cx="2286000" cy="0"/>
-          </a:xfrm>
-          <a:prstGeom prst="line">
-            <a:avLst/>
-          </a:prstGeom>
-          <a:noFill/>
-          <a:ln w="17780">
-            <a:solidFill>
-              <a:srgbClr val="C6D2E4"/>
-            </a:solidFill>
-            <a:prstDash val="dash"/>
-            <a:tailEnd type="triangle"/>
-          </a:ln>
-        </p:spPr>
-      </p:sp>
-      <p:sp>
-        <p:nvSpPr>
-          <p:cNvPr id="43" name="Text 41"/>
+            <a:pPr indent="0" marL="0">
+              <a:buNone/>
+            </a:pPr>
+            <a:r>
+              <a:rPr lang="en-US" sz="830" dirty="0">
+                <a:solidFill>
+                  <a:srgbClr val="5A6478"/>
+                </a:solidFill>
+                <a:latin typeface="Calibri" pitchFamily="34" charset="0"/>
+                <a:ea typeface="Calibri" pitchFamily="34" charset="-122"/>
+                <a:cs typeface="Calibri" pitchFamily="34" charset="-120"/>
+              </a:rPr>
+              <a:t>fm side suspect, re-running</a:t>
+            </a:r>
+            <a:endParaRPr lang="en-US" sz="830" dirty="0"/>
+          </a:p>
+        </p:txBody>
+      </p:sp>
+      <p:sp>
+        <p:nvSpPr>
+          <p:cNvPr id="27" name="Text 24"/>
           <p:cNvSpPr txBox="1"/>
           <p:nvPr/>
         </p:nvSpPr>
         <p:spPr>
           <a:xfrm>
-            <a:off x="822960" y="6035040"/>
-            <a:ext cx="5212080" cy="182880"/>
+            <a:off x="7818120" y="5623560"/>
+            <a:ext cx="3611880" cy="411480"/>
           </a:xfrm>
           <a:prstGeom prst="rect">
             <a:avLst/>
@@ -35498,52 +34997,30 @@
               <a:buNone/>
             </a:pPr>
             <a:r>
-              <a:rPr lang="en-US" sz="760" i="1" dirty="0">
-                <a:solidFill>
-                  <a:srgbClr val="AEBBD0"/>
-                </a:solidFill>
-                <a:latin typeface="Calibri" pitchFamily="34" charset="0"/>
-                <a:ea typeface="Calibri" pitchFamily="34" charset="-122"/>
-                <a:cs typeface="Calibri" pitchFamily="34" charset="-120"/>
-              </a:rPr>
-              <a:t>mediator: every host lever acts through S₅d (r = 0.89); Ms is set separately by Fe density and the RE. Interventions on the left are what a generative model may propose; the dashed edge is the Co trade-off.</a:t>
-            </a:r>
-            <a:endParaRPr lang="en-US" sz="760" dirty="0"/>
-          </a:p>
-        </p:txBody>
-      </p:sp>
-      <p:sp>
-        <p:nvSpPr>
-          <p:cNvPr id="44" name="Shape 42"/>
-          <p:cNvSpPr/>
-          <p:nvPr/>
-        </p:nvSpPr>
-        <p:spPr>
-          <a:xfrm>
-            <a:off x="6400800" y="4297680"/>
-            <a:ext cx="2514600" cy="1920240"/>
-          </a:xfrm>
-          <a:prstGeom prst="roundRect">
-            <a:avLst>
-              <a:gd name="adj" fmla="val 2857"/>
-            </a:avLst>
-          </a:prstGeom>
-          <a:solidFill>
-            <a:srgbClr val="1B2A4A"/>
-          </a:solidFill>
-          <a:ln/>
-        </p:spPr>
-      </p:sp>
-      <p:sp>
-        <p:nvSpPr>
-          <p:cNvPr id="45" name="Text 43"/>
+              <a:rPr lang="en-US" sz="900" i="1" dirty="0">
+                <a:solidFill>
+                  <a:srgbClr val="1A2233"/>
+                </a:solidFill>
+                <a:latin typeface="Calibri" pitchFamily="34" charset="0"/>
+                <a:ea typeface="Calibri" pitchFamily="34" charset="-122"/>
+                <a:cs typeface="Calibri" pitchFamily="34" charset="-120"/>
+              </a:rPr>
+              <a:t>Stop rule: a wave that adds no point to this line, after its labels are measured, has not moved the front. Two such waves in a row and the pool is exhausted for the current thresholds.</a:t>
+            </a:r>
+            <a:endParaRPr lang="en-US" sz="900" dirty="0"/>
+          </a:p>
+        </p:txBody>
+      </p:sp>
+      <p:sp>
+        <p:nvSpPr>
+          <p:cNvPr id="28" name="Text 25"/>
           <p:cNvSpPr txBox="1"/>
           <p:nvPr/>
         </p:nvSpPr>
         <p:spPr>
           <a:xfrm>
-            <a:off x="6565392" y="4389120"/>
-            <a:ext cx="2194560" cy="274320"/>
+            <a:off x="640080" y="6144768"/>
+            <a:ext cx="10881360" cy="457200"/>
           </a:xfrm>
           <a:prstGeom prst="rect">
             <a:avLst/>
@@ -35559,195 +35036,17 @@
               <a:buNone/>
             </a:pPr>
             <a:r>
-              <a:rPr lang="en-US" sz="1150" b="1" dirty="0">
-                <a:solidFill>
-                  <a:srgbClr val="F2B134"/>
-                </a:solidFill>
-                <a:latin typeface="Calibri" pitchFamily="34" charset="0"/>
-                <a:ea typeface="Calibri" pitchFamily="34" charset="-122"/>
-                <a:cs typeface="Calibri" pitchFamily="34" charset="-120"/>
-              </a:rPr>
-              <a:t>Gaussian process</a:t>
-            </a:r>
-            <a:endParaRPr lang="en-US" sz="1150" dirty="0"/>
-          </a:p>
-        </p:txBody>
-      </p:sp>
-      <p:sp>
-        <p:nvSpPr>
-          <p:cNvPr id="46" name="Text 44"/>
-          <p:cNvSpPr txBox="1"/>
-          <p:nvPr/>
-        </p:nvSpPr>
-        <p:spPr>
-          <a:xfrm>
-            <a:off x="6565392" y="4681728"/>
-            <a:ext cx="2212848" cy="1481328"/>
-          </a:xfrm>
-          <a:prstGeom prst="rect">
-            <a:avLst/>
-          </a:prstGeom>
-          <a:noFill/>
-          <a:ln/>
-        </p:spPr>
-        <p:txBody>
-          <a:bodyPr wrap="square" lIns="0" tIns="0" rIns="0" bIns="0" rtlCol="0" anchor="ctr"/>
-          <a:lstStyle/>
-          <a:p>
-            <a:pPr indent="0" marL="0">
-              <a:buNone/>
-            </a:pPr>
-            <a:r>
-              <a:rPr lang="en-US" sz="840" dirty="0">
-                <a:solidFill>
-                  <a:srgbClr val="C6D2E4"/>
-                </a:solidFill>
-                <a:latin typeface="Calibri" pitchFamily="34" charset="0"/>
-                <a:ea typeface="Calibri" pitchFamily="34" charset="-122"/>
-                <a:cs typeface="Calibri" pitchFamily="34" charset="-120"/>
-              </a:rPr>
-              <a:t>180 points, smooth physics descriptors, batch size fixed by one packed job. Mean function = 1574·h so the GP learns residuals; q-EI with a diversity penalty picks each batch. Each label is now ONE f-in-core run, so a round is 150-200 compounds per 25-node job.</a:t>
-            </a:r>
-            <a:endParaRPr lang="en-US" sz="840" dirty="0"/>
-          </a:p>
-        </p:txBody>
-      </p:sp>
-      <p:sp>
-        <p:nvSpPr>
-          <p:cNvPr id="47" name="Shape 45"/>
-          <p:cNvSpPr/>
-          <p:nvPr/>
-        </p:nvSpPr>
-        <p:spPr>
-          <a:xfrm>
-            <a:off x="9006840" y="4297680"/>
-            <a:ext cx="2514600" cy="1920240"/>
-          </a:xfrm>
-          <a:prstGeom prst="roundRect">
-            <a:avLst>
-              <a:gd name="adj" fmla="val 2857"/>
-            </a:avLst>
-          </a:prstGeom>
-          <a:solidFill>
-            <a:srgbClr val="1B2A4A"/>
-          </a:solidFill>
-          <a:ln/>
-        </p:spPr>
-      </p:sp>
-      <p:sp>
-        <p:nvSpPr>
-          <p:cNvPr id="48" name="Text 46"/>
-          <p:cNvSpPr txBox="1"/>
-          <p:nvPr/>
-        </p:nvSpPr>
-        <p:spPr>
-          <a:xfrm>
-            <a:off x="9171432" y="4389120"/>
-            <a:ext cx="2194560" cy="274320"/>
-          </a:xfrm>
-          <a:prstGeom prst="rect">
-            <a:avLst/>
-          </a:prstGeom>
-          <a:noFill/>
-          <a:ln/>
-        </p:spPr>
-        <p:txBody>
-          <a:bodyPr wrap="square" lIns="0" tIns="0" rIns="0" bIns="0" rtlCol="0" anchor="ctr"/>
-          <a:lstStyle/>
-          <a:p>
-            <a:pPr indent="0" marL="0">
-              <a:buNone/>
-            </a:pPr>
-            <a:r>
-              <a:rPr lang="en-US" sz="1150" b="1" dirty="0">
-                <a:solidFill>
-                  <a:srgbClr val="F2B134"/>
-                </a:solidFill>
-                <a:latin typeface="Calibri" pitchFamily="34" charset="0"/>
-                <a:ea typeface="Calibri" pitchFamily="34" charset="-122"/>
-                <a:cs typeface="Calibri" pitchFamily="34" charset="-120"/>
-              </a:rPr>
-              <a:t>Generative + causal</a:t>
-            </a:r>
-            <a:endParaRPr lang="en-US" sz="1150" dirty="0"/>
-          </a:p>
-        </p:txBody>
-      </p:sp>
-      <p:sp>
-        <p:nvSpPr>
-          <p:cNvPr id="49" name="Text 47"/>
-          <p:cNvSpPr txBox="1"/>
-          <p:nvPr/>
-        </p:nvSpPr>
-        <p:spPr>
-          <a:xfrm>
-            <a:off x="9171432" y="4681728"/>
-            <a:ext cx="2212848" cy="1481328"/>
-          </a:xfrm>
-          <a:prstGeom prst="rect">
-            <a:avLst/>
-          </a:prstGeom>
-          <a:noFill/>
-          <a:ln/>
-        </p:spPr>
-        <p:txBody>
-          <a:bodyPr wrap="square" lIns="0" tIns="0" rIns="0" bIns="0" rtlCol="0" anchor="ctr"/>
-          <a:lstStyle/>
-          <a:p>
-            <a:pPr indent="0" marL="0">
-              <a:buNone/>
-            </a:pPr>
-            <a:r>
-              <a:rPr lang="en-US" sz="840" dirty="0">
-                <a:solidFill>
-                  <a:srgbClr val="C6D2E4"/>
-                </a:solidFill>
-                <a:latin typeface="Calibri" pitchFamily="34" charset="0"/>
-                <a:ea typeface="Calibri" pitchFamily="34" charset="-122"/>
-                <a:cs typeface="Calibri" pitchFamily="34" charset="-120"/>
-              </a:rPr>
-              <a:t>The pool is exhausted above ≈ 1.75 T. A diffusion model conditioned on the causal parents - dense Fe, RE-TM &lt; 3.0 Å, 12-fold coordination, partial Co, no H in the RE shell - proposes frameworks; MACE hull filters; the causal graph tells it which knobs are real and which are confounded.</a:t>
-            </a:r>
-            <a:endParaRPr lang="en-US" sz="840" dirty="0"/>
-          </a:p>
-        </p:txBody>
-      </p:sp>
-      <p:sp>
-        <p:nvSpPr>
-          <p:cNvPr id="50" name="Text 48"/>
-          <p:cNvSpPr txBox="1"/>
-          <p:nvPr/>
-        </p:nvSpPr>
-        <p:spPr>
-          <a:xfrm>
-            <a:off x="640080" y="6327648"/>
-            <a:ext cx="10881360" cy="320040"/>
-          </a:xfrm>
-          <a:prstGeom prst="rect">
-            <a:avLst/>
-          </a:prstGeom>
-          <a:noFill/>
-          <a:ln/>
-        </p:spPr>
-        <p:txBody>
-          <a:bodyPr wrap="square" lIns="0" tIns="0" rIns="0" bIns="0" rtlCol="0" anchor="ctr"/>
-          <a:lstStyle/>
-          <a:p>
-            <a:pPr indent="0" marL="0">
-              <a:buNone/>
-            </a:pPr>
-            <a:r>
-              <a:rPr lang="en-US" sz="1100" i="1" dirty="0">
-                <a:solidFill>
-                  <a:srgbClr val="8FA3C0"/>
-                </a:solidFill>
-                <a:latin typeface="Calibri" pitchFamily="34" charset="0"/>
-                <a:ea typeface="Calibri" pitchFamily="34" charset="-122"/>
-                <a:cs typeface="Calibri" pitchFamily="34" charset="-120"/>
-              </a:rPr>
-              <a:t>The campaign's product is not a compound; it is a calibrated instrument for RE-TM exchange and the first dataset a learning loop can be trained on.</a:t>
-            </a:r>
-            <a:endParaRPr lang="en-US" sz="1100" dirty="0"/>
+              <a:rPr lang="en-US" sz="1050" i="1" dirty="0">
+                <a:solidFill>
+                  <a:srgbClr val="1A2233"/>
+                </a:solidFill>
+                <a:latin typeface="Calibri" pitchFamily="34" charset="0"/>
+                <a:ea typeface="Calibri" pitchFamily="34" charset="-122"/>
+                <a:cs typeface="Calibri" pitchFamily="34" charset="-120"/>
+              </a:rPr>
+              <a:t>Learnt: the front is the known magnets plus RE-rich cells; every point on it is either a reference compound or fails the hull or the coupling floor. The target region, upper right of both dashed lines, is empty - that is the space the waves are drawn to fill.</a:t>
+            </a:r>
+            <a:endParaRPr lang="en-US" sz="1050" dirty="0"/>
           </a:p>
         </p:txBody>
       </p:sp>
@@ -36844,6 +36143,1876 @@
               <a:t>Criteria 5 and 6 are deliberately permissive: an unlabelled compound is a candidate, not a rejection.</a:t>
             </a:r>
             <a:endParaRPr lang="en-US" sz="1200" dirty="0"/>
+          </a:p>
+        </p:txBody>
+      </p:sp>
+    </p:spTree>
+  </p:cSld>
+  <p:clrMapOvr>
+    <a:masterClrMapping/>
+  </p:clrMapOvr>
+</p:sld>
+</file>
+
+<file path=ppt/slides/slide30.xml><?xml version="1.0" encoding="utf-8"?>
+<p:sld xmlns:a="http://schemas.openxmlformats.org/drawingml/2006/main" xmlns:r="http://schemas.openxmlformats.org/officeDocument/2006/relationships" xmlns:p="http://schemas.openxmlformats.org/presentationml/2006/main">
+  <p:cSld name="Slide 30">
+    <p:bg>
+      <p:bgPr>
+        <a:solidFill>
+          <a:srgbClr val="101B33"/>
+        </a:solidFill>
+      </p:bgPr>
+    </p:bg>
+    <p:spTree>
+      <p:nvGrpSpPr>
+        <p:cNvPr id="1" name=""/>
+        <p:cNvGrpSpPr/>
+        <p:nvPr/>
+      </p:nvGrpSpPr>
+      <p:grpSpPr>
+        <a:xfrm>
+          <a:off x="0" y="0"/>
+          <a:ext cx="0" cy="0"/>
+          <a:chOff x="0" y="0"/>
+          <a:chExt cx="0" cy="0"/>
+        </a:xfrm>
+      </p:grpSpPr>
+      <p:sp>
+        <p:nvSpPr>
+          <p:cNvPr id="2" name="Text 0"/>
+          <p:cNvSpPr txBox="1"/>
+          <p:nvPr/>
+        </p:nvSpPr>
+        <p:spPr>
+          <a:xfrm>
+            <a:off x="640080" y="347472"/>
+            <a:ext cx="10881360" cy="237744"/>
+          </a:xfrm>
+          <a:prstGeom prst="rect">
+            <a:avLst/>
+          </a:prstGeom>
+          <a:noFill/>
+          <a:ln/>
+        </p:spPr>
+        <p:txBody>
+          <a:bodyPr wrap="square" lIns="0" tIns="0" rIns="0" bIns="0" rtlCol="0" anchor="ctr"/>
+          <a:lstStyle/>
+          <a:p>
+            <a:pPr indent="0" marL="0">
+              <a:buNone/>
+            </a:pPr>
+            <a:r>
+              <a:rPr lang="en-US" sz="1200" b="1" spc="200" kern="0" dirty="0">
+                <a:solidFill>
+                  <a:srgbClr val="F2B134"/>
+                </a:solidFill>
+                <a:latin typeface="Calibri" pitchFamily="34" charset="0"/>
+                <a:ea typeface="Calibri" pitchFamily="34" charset="-122"/>
+                <a:cs typeface="Calibri" pitchFamily="34" charset="-120"/>
+              </a:rPr>
+              <a:t>CLOSING THE LOOP</a:t>
+            </a:r>
+            <a:endParaRPr lang="en-US" sz="1200" dirty="0"/>
+          </a:p>
+        </p:txBody>
+      </p:sp>
+      <p:sp>
+        <p:nvSpPr>
+          <p:cNvPr id="3" name="Text 1"/>
+          <p:cNvSpPr txBox="1"/>
+          <p:nvPr/>
+        </p:nvSpPr>
+        <p:spPr>
+          <a:xfrm>
+            <a:off x="640080" y="603504"/>
+            <a:ext cx="10881360" cy="658368"/>
+          </a:xfrm>
+          <a:prstGeom prst="rect">
+            <a:avLst/>
+          </a:prstGeom>
+          <a:noFill/>
+          <a:ln/>
+        </p:spPr>
+        <p:txBody>
+          <a:bodyPr wrap="square" lIns="0" tIns="0" rIns="0" bIns="0" rtlCol="0" anchor="ctr"/>
+          <a:lstStyle/>
+          <a:p>
+            <a:pPr indent="0" marL="0">
+              <a:buNone/>
+            </a:pPr>
+            <a:r>
+              <a:rPr lang="en-US" sz="3200" b="1" dirty="0">
+                <a:solidFill>
+                  <a:srgbClr val="FFFFFF"/>
+                </a:solidFill>
+                <a:latin typeface="Cambria" pitchFamily="34" charset="0"/>
+                <a:ea typeface="Cambria" pitchFamily="34" charset="-122"/>
+                <a:cs typeface="Cambria" pitchFamily="34" charset="-120"/>
+              </a:rPr>
+              <a:t>Gaussian process for where to look, causal model for which lever, generative model for what to propose</a:t>
+            </a:r>
+            <a:endParaRPr lang="en-US" sz="3200" dirty="0"/>
+          </a:p>
+        </p:txBody>
+      </p:sp>
+      <p:sp>
+        <p:nvSpPr>
+          <p:cNvPr id="4" name="Shape 2"/>
+          <p:cNvSpPr/>
+          <p:nvPr/>
+        </p:nvSpPr>
+        <p:spPr>
+          <a:xfrm>
+            <a:off x="640080" y="1600200"/>
+            <a:ext cx="2029968" cy="1783080"/>
+          </a:xfrm>
+          <a:prstGeom prst="roundRect">
+            <a:avLst>
+              <a:gd name="adj" fmla="val 4103"/>
+            </a:avLst>
+          </a:prstGeom>
+          <a:solidFill>
+            <a:srgbClr val="2E86AB"/>
+          </a:solidFill>
+          <a:ln/>
+        </p:spPr>
+      </p:sp>
+      <p:sp>
+        <p:nvSpPr>
+          <p:cNvPr id="5" name="Text 3"/>
+          <p:cNvSpPr txBox="1"/>
+          <p:nvPr/>
+        </p:nvSpPr>
+        <p:spPr>
+          <a:xfrm>
+            <a:off x="749808" y="1700784"/>
+            <a:ext cx="1810512" cy="329184"/>
+          </a:xfrm>
+          <a:prstGeom prst="rect">
+            <a:avLst/>
+          </a:prstGeom>
+          <a:noFill/>
+          <a:ln/>
+        </p:spPr>
+        <p:txBody>
+          <a:bodyPr wrap="square" lIns="0" tIns="0" rIns="0" bIns="0" rtlCol="0" anchor="ctr"/>
+          <a:lstStyle/>
+          <a:p>
+            <a:pPr algn="ctr" indent="0" marL="0">
+              <a:buNone/>
+            </a:pPr>
+            <a:r>
+              <a:rPr lang="en-US" sz="1250" b="1" dirty="0">
+                <a:solidFill>
+                  <a:srgbClr val="FFFFFF"/>
+                </a:solidFill>
+                <a:latin typeface="Calibri" pitchFamily="34" charset="0"/>
+                <a:ea typeface="Calibri" pitchFamily="34" charset="-122"/>
+                <a:cs typeface="Calibri" pitchFamily="34" charset="-120"/>
+              </a:rPr>
+              <a:t>Labelled data</a:t>
+            </a:r>
+            <a:endParaRPr lang="en-US" sz="1250" dirty="0"/>
+          </a:p>
+        </p:txBody>
+      </p:sp>
+      <p:sp>
+        <p:nvSpPr>
+          <p:cNvPr id="6" name="Text 4"/>
+          <p:cNvSpPr txBox="1"/>
+          <p:nvPr/>
+        </p:nvSpPr>
+        <p:spPr>
+          <a:xfrm>
+            <a:off x="749808" y="2066544"/>
+            <a:ext cx="1810512" cy="1261872"/>
+          </a:xfrm>
+          <a:prstGeom prst="rect">
+            <a:avLst/>
+          </a:prstGeom>
+          <a:noFill/>
+          <a:ln/>
+        </p:spPr>
+        <p:txBody>
+          <a:bodyPr wrap="square" lIns="0" tIns="0" rIns="0" bIns="0" rtlCol="0" anchor="ctr"/>
+          <a:lstStyle/>
+          <a:p>
+            <a:pPr algn="ctr" indent="0" marL="0">
+              <a:buNone/>
+            </a:pPr>
+            <a:r>
+              <a:rPr lang="en-US" sz="860" dirty="0">
+                <a:solidFill>
+                  <a:srgbClr val="F0F4FA"/>
+                </a:solidFill>
+                <a:latin typeface="Calibri" pitchFamily="34" charset="0"/>
+                <a:ea typeface="Calibri" pitchFamily="34" charset="-122"/>
+                <a:cs typeface="Calibri" pitchFamily="34" charset="-120"/>
+              </a:rPr>
+              <a:t>180 Gd pairs → gap, h, moments, geometry</a:t>
+            </a:r>
+            <a:endParaRPr lang="en-US" sz="860" dirty="0"/>
+          </a:p>
+          <a:p>
+            <a:pPr algn="ctr" indent="0" marL="0">
+              <a:buNone/>
+            </a:pPr>
+            <a:r>
+              <a:rPr lang="en-US" sz="860" dirty="0">
+                <a:solidFill>
+                  <a:srgbClr val="F0F4FA"/>
+                </a:solidFill>
+                <a:latin typeface="Calibri" pitchFamily="34" charset="0"/>
+                <a:ea typeface="Calibri" pitchFamily="34" charset="-122"/>
+                <a:cs typeface="Calibri" pitchFamily="34" charset="-120"/>
+              </a:rPr>
+              <a:t>+ 20 light-RE runs</a:t>
+            </a:r>
+            <a:endParaRPr lang="en-US" sz="860" dirty="0"/>
+          </a:p>
+          <a:p>
+            <a:pPr algn="ctr" indent="0" marL="0">
+              <a:buNone/>
+            </a:pPr>
+            <a:r>
+              <a:rPr lang="en-US" sz="860" dirty="0">
+                <a:solidFill>
+                  <a:srgbClr val="F0F4FA"/>
+                </a:solidFill>
+                <a:latin typeface="Calibri" pitchFamily="34" charset="0"/>
+                <a:ea typeface="Calibri" pitchFamily="34" charset="-122"/>
+                <a:cs typeface="Calibri" pitchFamily="34" charset="-120"/>
+              </a:rPr>
+              <a:t>+ MACE hull for every cell</a:t>
+            </a:r>
+            <a:endParaRPr lang="en-US" sz="860" dirty="0"/>
+          </a:p>
+        </p:txBody>
+      </p:sp>
+      <p:sp>
+        <p:nvSpPr>
+          <p:cNvPr id="7" name="Text 5"/>
+          <p:cNvSpPr txBox="1"/>
+          <p:nvPr/>
+        </p:nvSpPr>
+        <p:spPr>
+          <a:xfrm>
+            <a:off x="2651760" y="2286000"/>
+            <a:ext cx="274320" cy="365760"/>
+          </a:xfrm>
+          <a:prstGeom prst="rect">
+            <a:avLst/>
+          </a:prstGeom>
+          <a:noFill/>
+          <a:ln/>
+        </p:spPr>
+        <p:txBody>
+          <a:bodyPr wrap="square" lIns="0" tIns="0" rIns="0" bIns="0" rtlCol="0" anchor="ctr"/>
+          <a:lstStyle/>
+          <a:p>
+            <a:pPr algn="ctr" indent="0" marL="0">
+              <a:buNone/>
+            </a:pPr>
+            <a:r>
+              <a:rPr lang="en-US" sz="1800" b="1" dirty="0">
+                <a:solidFill>
+                  <a:srgbClr val="8FA3C0"/>
+                </a:solidFill>
+                <a:latin typeface="Arial" pitchFamily="34" charset="0"/>
+                <a:ea typeface="Arial" pitchFamily="34" charset="-122"/>
+                <a:cs typeface="Arial" pitchFamily="34" charset="-120"/>
+              </a:rPr>
+              <a:t>→</a:t>
+            </a:r>
+            <a:endParaRPr lang="en-US" sz="1800" dirty="0"/>
+          </a:p>
+        </p:txBody>
+      </p:sp>
+      <p:sp>
+        <p:nvSpPr>
+          <p:cNvPr id="8" name="Shape 6"/>
+          <p:cNvSpPr/>
+          <p:nvPr/>
+        </p:nvSpPr>
+        <p:spPr>
+          <a:xfrm>
+            <a:off x="2907792" y="1600200"/>
+            <a:ext cx="2029968" cy="1783080"/>
+          </a:xfrm>
+          <a:prstGeom prst="roundRect">
+            <a:avLst>
+              <a:gd name="adj" fmla="val 4103"/>
+            </a:avLst>
+          </a:prstGeom>
+          <a:solidFill>
+            <a:srgbClr val="3E7FA6"/>
+          </a:solidFill>
+          <a:ln/>
+        </p:spPr>
+      </p:sp>
+      <p:sp>
+        <p:nvSpPr>
+          <p:cNvPr id="9" name="Text 7"/>
+          <p:cNvSpPr txBox="1"/>
+          <p:nvPr/>
+        </p:nvSpPr>
+        <p:spPr>
+          <a:xfrm>
+            <a:off x="3017520" y="1700784"/>
+            <a:ext cx="1810512" cy="329184"/>
+          </a:xfrm>
+          <a:prstGeom prst="rect">
+            <a:avLst/>
+          </a:prstGeom>
+          <a:noFill/>
+          <a:ln/>
+        </p:spPr>
+        <p:txBody>
+          <a:bodyPr wrap="square" lIns="0" tIns="0" rIns="0" bIns="0" rtlCol="0" anchor="ctr"/>
+          <a:lstStyle/>
+          <a:p>
+            <a:pPr algn="ctr" indent="0" marL="0">
+              <a:buNone/>
+            </a:pPr>
+            <a:r>
+              <a:rPr lang="en-US" sz="1250" b="1" dirty="0">
+                <a:solidFill>
+                  <a:srgbClr val="FFFFFF"/>
+                </a:solidFill>
+                <a:latin typeface="Calibri" pitchFamily="34" charset="0"/>
+                <a:ea typeface="Calibri" pitchFamily="34" charset="-122"/>
+                <a:cs typeface="Calibri" pitchFamily="34" charset="-120"/>
+              </a:rPr>
+              <a:t>Gaussian process</a:t>
+            </a:r>
+            <a:endParaRPr lang="en-US" sz="1250" dirty="0"/>
+          </a:p>
+        </p:txBody>
+      </p:sp>
+      <p:sp>
+        <p:nvSpPr>
+          <p:cNvPr id="10" name="Text 8"/>
+          <p:cNvSpPr txBox="1"/>
+          <p:nvPr/>
+        </p:nvSpPr>
+        <p:spPr>
+          <a:xfrm>
+            <a:off x="3017520" y="2066544"/>
+            <a:ext cx="1810512" cy="1261872"/>
+          </a:xfrm>
+          <a:prstGeom prst="rect">
+            <a:avLst/>
+          </a:prstGeom>
+          <a:noFill/>
+          <a:ln/>
+        </p:spPr>
+        <p:txBody>
+          <a:bodyPr wrap="square" lIns="0" tIns="0" rIns="0" bIns="0" rtlCol="0" anchor="ctr"/>
+          <a:lstStyle/>
+          <a:p>
+            <a:pPr algn="ctr" indent="0" marL="0">
+              <a:buNone/>
+            </a:pPr>
+            <a:r>
+              <a:rPr lang="en-US" sz="860" dirty="0">
+                <a:solidFill>
+                  <a:srgbClr val="F0F4FA"/>
+                </a:solidFill>
+                <a:latin typeface="Calibri" pitchFamily="34" charset="0"/>
+                <a:ea typeface="Calibri" pitchFamily="34" charset="-122"/>
+                <a:cs typeface="Calibri" pitchFamily="34" charset="-120"/>
+              </a:rPr>
+              <a:t>on physics descriptors (h, Fe density,</a:t>
+            </a:r>
+            <a:endParaRPr lang="en-US" sz="860" dirty="0"/>
+          </a:p>
+          <a:p>
+            <a:pPr algn="ctr" indent="0" marL="0">
+              <a:buNone/>
+            </a:pPr>
+            <a:r>
+              <a:rPr lang="en-US" sz="860" dirty="0">
+                <a:solidFill>
+                  <a:srgbClr val="F0F4FA"/>
+                </a:solidFill>
+                <a:latin typeface="Calibri" pitchFamily="34" charset="0"/>
+                <a:ea typeface="Calibri" pitchFamily="34" charset="-122"/>
+                <a:cs typeface="Calibri" pitchFamily="34" charset="-120"/>
+              </a:rPr>
+              <a:t>d_RE-TM, Z_RT, Co fraction, interstitial)</a:t>
+            </a:r>
+            <a:endParaRPr lang="en-US" sz="860" dirty="0"/>
+          </a:p>
+          <a:p>
+            <a:pPr algn="ctr" indent="0" marL="0">
+              <a:buNone/>
+            </a:pPr>
+            <a:r>
+              <a:rPr lang="en-US" sz="860" dirty="0">
+                <a:solidFill>
+                  <a:srgbClr val="F0F4FA"/>
+                </a:solidFill>
+                <a:latin typeface="Calibri" pitchFamily="34" charset="0"/>
+                <a:ea typeface="Calibri" pitchFamily="34" charset="-122"/>
+                <a:cs typeface="Calibri" pitchFamily="34" charset="-120"/>
+              </a:rPr>
+              <a:t>→ gap, Ms, E_hull with uncertainty</a:t>
+            </a:r>
+            <a:endParaRPr lang="en-US" sz="860" dirty="0"/>
+          </a:p>
+        </p:txBody>
+      </p:sp>
+      <p:sp>
+        <p:nvSpPr>
+          <p:cNvPr id="11" name="Text 9"/>
+          <p:cNvSpPr txBox="1"/>
+          <p:nvPr/>
+        </p:nvSpPr>
+        <p:spPr>
+          <a:xfrm>
+            <a:off x="4919472" y="2286000"/>
+            <a:ext cx="274320" cy="365760"/>
+          </a:xfrm>
+          <a:prstGeom prst="rect">
+            <a:avLst/>
+          </a:prstGeom>
+          <a:noFill/>
+          <a:ln/>
+        </p:spPr>
+        <p:txBody>
+          <a:bodyPr wrap="square" lIns="0" tIns="0" rIns="0" bIns="0" rtlCol="0" anchor="ctr"/>
+          <a:lstStyle/>
+          <a:p>
+            <a:pPr algn="ctr" indent="0" marL="0">
+              <a:buNone/>
+            </a:pPr>
+            <a:r>
+              <a:rPr lang="en-US" sz="1800" b="1" dirty="0">
+                <a:solidFill>
+                  <a:srgbClr val="8FA3C0"/>
+                </a:solidFill>
+                <a:latin typeface="Arial" pitchFamily="34" charset="0"/>
+                <a:ea typeface="Arial" pitchFamily="34" charset="-122"/>
+                <a:cs typeface="Arial" pitchFamily="34" charset="-120"/>
+              </a:rPr>
+              <a:t>→</a:t>
+            </a:r>
+            <a:endParaRPr lang="en-US" sz="1800" dirty="0"/>
+          </a:p>
+        </p:txBody>
+      </p:sp>
+      <p:sp>
+        <p:nvSpPr>
+          <p:cNvPr id="12" name="Shape 10"/>
+          <p:cNvSpPr/>
+          <p:nvPr/>
+        </p:nvSpPr>
+        <p:spPr>
+          <a:xfrm>
+            <a:off x="5175504" y="1600200"/>
+            <a:ext cx="2029968" cy="1783080"/>
+          </a:xfrm>
+          <a:prstGeom prst="roundRect">
+            <a:avLst>
+              <a:gd name="adj" fmla="val 4103"/>
+            </a:avLst>
+          </a:prstGeom>
+          <a:solidFill>
+            <a:srgbClr val="F2B134"/>
+          </a:solidFill>
+          <a:ln/>
+        </p:spPr>
+      </p:sp>
+      <p:sp>
+        <p:nvSpPr>
+          <p:cNvPr id="13" name="Text 11"/>
+          <p:cNvSpPr txBox="1"/>
+          <p:nvPr/>
+        </p:nvSpPr>
+        <p:spPr>
+          <a:xfrm>
+            <a:off x="5285232" y="1700784"/>
+            <a:ext cx="1810512" cy="329184"/>
+          </a:xfrm>
+          <a:prstGeom prst="rect">
+            <a:avLst/>
+          </a:prstGeom>
+          <a:noFill/>
+          <a:ln/>
+        </p:spPr>
+        <p:txBody>
+          <a:bodyPr wrap="square" lIns="0" tIns="0" rIns="0" bIns="0" rtlCol="0" anchor="ctr"/>
+          <a:lstStyle/>
+          <a:p>
+            <a:pPr algn="ctr" indent="0" marL="0">
+              <a:buNone/>
+            </a:pPr>
+            <a:r>
+              <a:rPr lang="en-US" sz="1250" b="1" dirty="0">
+                <a:solidFill>
+                  <a:srgbClr val="FFFFFF"/>
+                </a:solidFill>
+                <a:latin typeface="Calibri" pitchFamily="34" charset="0"/>
+                <a:ea typeface="Calibri" pitchFamily="34" charset="-122"/>
+                <a:cs typeface="Calibri" pitchFamily="34" charset="-120"/>
+              </a:rPr>
+              <a:t>Causal layer</a:t>
+            </a:r>
+            <a:endParaRPr lang="en-US" sz="1250" dirty="0"/>
+          </a:p>
+        </p:txBody>
+      </p:sp>
+      <p:sp>
+        <p:nvSpPr>
+          <p:cNvPr id="14" name="Text 12"/>
+          <p:cNvSpPr txBox="1"/>
+          <p:nvPr/>
+        </p:nvSpPr>
+        <p:spPr>
+          <a:xfrm>
+            <a:off x="5285232" y="2066544"/>
+            <a:ext cx="1810512" cy="1261872"/>
+          </a:xfrm>
+          <a:prstGeom prst="rect">
+            <a:avLst/>
+          </a:prstGeom>
+          <a:noFill/>
+          <a:ln/>
+        </p:spPr>
+        <p:txBody>
+          <a:bodyPr wrap="square" lIns="0" tIns="0" rIns="0" bIns="0" rtlCol="0" anchor="ctr"/>
+          <a:lstStyle/>
+          <a:p>
+            <a:pPr algn="ctr" indent="0" marL="0">
+              <a:buNone/>
+            </a:pPr>
+            <a:r>
+              <a:rPr lang="en-US" sz="860" dirty="0">
+                <a:solidFill>
+                  <a:srgbClr val="F0F4FA"/>
+                </a:solidFill>
+                <a:latin typeface="Calibri" pitchFamily="34" charset="0"/>
+                <a:ea typeface="Calibri" pitchFamily="34" charset="-122"/>
+                <a:cs typeface="Calibri" pitchFamily="34" charset="-120"/>
+              </a:rPr>
+              <a:t>structural causal model</a:t>
+            </a:r>
+            <a:endParaRPr lang="en-US" sz="860" dirty="0"/>
+          </a:p>
+          <a:p>
+            <a:pPr algn="ctr" indent="0" marL="0">
+              <a:buNone/>
+            </a:pPr>
+            <a:r>
+              <a:rPr lang="en-US" sz="860" dirty="0">
+                <a:solidFill>
+                  <a:srgbClr val="F0F4FA"/>
+                </a:solidFill>
+                <a:latin typeface="Calibri" pitchFamily="34" charset="0"/>
+                <a:ea typeface="Calibri" pitchFamily="34" charset="-122"/>
+                <a:cs typeface="Calibri" pitchFamily="34" charset="-120"/>
+              </a:rPr>
+              <a:t>host → S₅d → gap; interventions,</a:t>
+            </a:r>
+            <a:endParaRPr lang="en-US" sz="860" dirty="0"/>
+          </a:p>
+          <a:p>
+            <a:pPr algn="ctr" indent="0" marL="0">
+              <a:buNone/>
+            </a:pPr>
+            <a:r>
+              <a:rPr lang="en-US" sz="860" dirty="0">
+                <a:solidFill>
+                  <a:srgbClr val="F0F4FA"/>
+                </a:solidFill>
+                <a:latin typeface="Calibri" pitchFamily="34" charset="0"/>
+                <a:ea typeface="Calibri" pitchFamily="34" charset="-122"/>
+                <a:cs typeface="Calibri" pitchFamily="34" charset="-120"/>
+              </a:rPr>
+              <a:t>not correlations, rank the levers</a:t>
+            </a:r>
+            <a:endParaRPr lang="en-US" sz="860" dirty="0"/>
+          </a:p>
+        </p:txBody>
+      </p:sp>
+      <p:sp>
+        <p:nvSpPr>
+          <p:cNvPr id="15" name="Text 13"/>
+          <p:cNvSpPr txBox="1"/>
+          <p:nvPr/>
+        </p:nvSpPr>
+        <p:spPr>
+          <a:xfrm>
+            <a:off x="7187184" y="2286000"/>
+            <a:ext cx="274320" cy="365760"/>
+          </a:xfrm>
+          <a:prstGeom prst="rect">
+            <a:avLst/>
+          </a:prstGeom>
+          <a:noFill/>
+          <a:ln/>
+        </p:spPr>
+        <p:txBody>
+          <a:bodyPr wrap="square" lIns="0" tIns="0" rIns="0" bIns="0" rtlCol="0" anchor="ctr"/>
+          <a:lstStyle/>
+          <a:p>
+            <a:pPr algn="ctr" indent="0" marL="0">
+              <a:buNone/>
+            </a:pPr>
+            <a:r>
+              <a:rPr lang="en-US" sz="1800" b="1" dirty="0">
+                <a:solidFill>
+                  <a:srgbClr val="8FA3C0"/>
+                </a:solidFill>
+                <a:latin typeface="Arial" pitchFamily="34" charset="0"/>
+                <a:ea typeface="Arial" pitchFamily="34" charset="-122"/>
+                <a:cs typeface="Arial" pitchFamily="34" charset="-120"/>
+              </a:rPr>
+              <a:t>→</a:t>
+            </a:r>
+            <a:endParaRPr lang="en-US" sz="1800" dirty="0"/>
+          </a:p>
+        </p:txBody>
+      </p:sp>
+      <p:sp>
+        <p:nvSpPr>
+          <p:cNvPr id="16" name="Shape 14"/>
+          <p:cNvSpPr/>
+          <p:nvPr/>
+        </p:nvSpPr>
+        <p:spPr>
+          <a:xfrm>
+            <a:off x="7443216" y="1600200"/>
+            <a:ext cx="2029968" cy="1783080"/>
+          </a:xfrm>
+          <a:prstGeom prst="roundRect">
+            <a:avLst>
+              <a:gd name="adj" fmla="val 4103"/>
+            </a:avLst>
+          </a:prstGeom>
+          <a:solidFill>
+            <a:srgbClr val="E4572E"/>
+          </a:solidFill>
+          <a:ln/>
+        </p:spPr>
+      </p:sp>
+      <p:sp>
+        <p:nvSpPr>
+          <p:cNvPr id="17" name="Text 15"/>
+          <p:cNvSpPr txBox="1"/>
+          <p:nvPr/>
+        </p:nvSpPr>
+        <p:spPr>
+          <a:xfrm>
+            <a:off x="7552944" y="1700784"/>
+            <a:ext cx="1810512" cy="329184"/>
+          </a:xfrm>
+          <a:prstGeom prst="rect">
+            <a:avLst/>
+          </a:prstGeom>
+          <a:noFill/>
+          <a:ln/>
+        </p:spPr>
+        <p:txBody>
+          <a:bodyPr wrap="square" lIns="0" tIns="0" rIns="0" bIns="0" rtlCol="0" anchor="ctr"/>
+          <a:lstStyle/>
+          <a:p>
+            <a:pPr algn="ctr" indent="0" marL="0">
+              <a:buNone/>
+            </a:pPr>
+            <a:r>
+              <a:rPr lang="en-US" sz="1250" b="1" dirty="0">
+                <a:solidFill>
+                  <a:srgbClr val="FFFFFF"/>
+                </a:solidFill>
+                <a:latin typeface="Calibri" pitchFamily="34" charset="0"/>
+                <a:ea typeface="Calibri" pitchFamily="34" charset="-122"/>
+                <a:cs typeface="Calibri" pitchFamily="34" charset="-120"/>
+              </a:rPr>
+              <a:t>Generative proposal</a:t>
+            </a:r>
+            <a:endParaRPr lang="en-US" sz="1250" dirty="0"/>
+          </a:p>
+        </p:txBody>
+      </p:sp>
+      <p:sp>
+        <p:nvSpPr>
+          <p:cNvPr id="18" name="Text 16"/>
+          <p:cNvSpPr txBox="1"/>
+          <p:nvPr/>
+        </p:nvSpPr>
+        <p:spPr>
+          <a:xfrm>
+            <a:off x="7552944" y="2066544"/>
+            <a:ext cx="1810512" cy="1261872"/>
+          </a:xfrm>
+          <a:prstGeom prst="rect">
+            <a:avLst/>
+          </a:prstGeom>
+          <a:noFill/>
+          <a:ln/>
+        </p:spPr>
+        <p:txBody>
+          <a:bodyPr wrap="square" lIns="0" tIns="0" rIns="0" bIns="0" rtlCol="0" anchor="ctr"/>
+          <a:lstStyle/>
+          <a:p>
+            <a:pPr algn="ctr" indent="0" marL="0">
+              <a:buNone/>
+            </a:pPr>
+            <a:r>
+              <a:rPr lang="en-US" sz="860" dirty="0">
+                <a:solidFill>
+                  <a:srgbClr val="F0F4FA"/>
+                </a:solidFill>
+                <a:latin typeface="Calibri" pitchFamily="34" charset="0"/>
+                <a:ea typeface="Calibri" pitchFamily="34" charset="-122"/>
+                <a:cs typeface="Calibri" pitchFamily="34" charset="-120"/>
+              </a:rPr>
+              <a:t>diffusion / MatterGen conditioned on</a:t>
+            </a:r>
+            <a:endParaRPr lang="en-US" sz="860" dirty="0"/>
+          </a:p>
+          <a:p>
+            <a:pPr algn="ctr" indent="0" marL="0">
+              <a:buNone/>
+            </a:pPr>
+            <a:r>
+              <a:rPr lang="en-US" sz="860" dirty="0">
+                <a:solidFill>
+                  <a:srgbClr val="F0F4FA"/>
+                </a:solidFill>
+                <a:latin typeface="Calibri" pitchFamily="34" charset="0"/>
+                <a:ea typeface="Calibri" pitchFamily="34" charset="-122"/>
+                <a:cs typeface="Calibri" pitchFamily="34" charset="-120"/>
+              </a:rPr>
+              <a:t>dense Fe, short RE-TM, early TM;</a:t>
+            </a:r>
+            <a:endParaRPr lang="en-US" sz="860" dirty="0"/>
+          </a:p>
+          <a:p>
+            <a:pPr algn="ctr" indent="0" marL="0">
+              <a:buNone/>
+            </a:pPr>
+            <a:r>
+              <a:rPr lang="en-US" sz="860" dirty="0">
+                <a:solidFill>
+                  <a:srgbClr val="F0F4FA"/>
+                </a:solidFill>
+                <a:latin typeface="Calibri" pitchFamily="34" charset="0"/>
+                <a:ea typeface="Calibri" pitchFamily="34" charset="-122"/>
+                <a:cs typeface="Calibri" pitchFamily="34" charset="-120"/>
+              </a:rPr>
+              <a:t>MACE hull as the first filter</a:t>
+            </a:r>
+            <a:endParaRPr lang="en-US" sz="860" dirty="0"/>
+          </a:p>
+        </p:txBody>
+      </p:sp>
+      <p:sp>
+        <p:nvSpPr>
+          <p:cNvPr id="19" name="Text 17"/>
+          <p:cNvSpPr txBox="1"/>
+          <p:nvPr/>
+        </p:nvSpPr>
+        <p:spPr>
+          <a:xfrm>
+            <a:off x="9454896" y="2286000"/>
+            <a:ext cx="274320" cy="365760"/>
+          </a:xfrm>
+          <a:prstGeom prst="rect">
+            <a:avLst/>
+          </a:prstGeom>
+          <a:noFill/>
+          <a:ln/>
+        </p:spPr>
+        <p:txBody>
+          <a:bodyPr wrap="square" lIns="0" tIns="0" rIns="0" bIns="0" rtlCol="0" anchor="ctr"/>
+          <a:lstStyle/>
+          <a:p>
+            <a:pPr algn="ctr" indent="0" marL="0">
+              <a:buNone/>
+            </a:pPr>
+            <a:r>
+              <a:rPr lang="en-US" sz="1800" b="1" dirty="0">
+                <a:solidFill>
+                  <a:srgbClr val="8FA3C0"/>
+                </a:solidFill>
+                <a:latin typeface="Arial" pitchFamily="34" charset="0"/>
+                <a:ea typeface="Arial" pitchFamily="34" charset="-122"/>
+                <a:cs typeface="Arial" pitchFamily="34" charset="-120"/>
+              </a:rPr>
+              <a:t>→</a:t>
+            </a:r>
+            <a:endParaRPr lang="en-US" sz="1800" dirty="0"/>
+          </a:p>
+        </p:txBody>
+      </p:sp>
+      <p:sp>
+        <p:nvSpPr>
+          <p:cNvPr id="20" name="Shape 18"/>
+          <p:cNvSpPr/>
+          <p:nvPr/>
+        </p:nvSpPr>
+        <p:spPr>
+          <a:xfrm>
+            <a:off x="9710928" y="1600200"/>
+            <a:ext cx="2029968" cy="1783080"/>
+          </a:xfrm>
+          <a:prstGeom prst="roundRect">
+            <a:avLst>
+              <a:gd name="adj" fmla="val 4103"/>
+            </a:avLst>
+          </a:prstGeom>
+          <a:solidFill>
+            <a:srgbClr val="C6472A"/>
+          </a:solidFill>
+          <a:ln/>
+        </p:spPr>
+      </p:sp>
+      <p:sp>
+        <p:nvSpPr>
+          <p:cNvPr id="21" name="Text 19"/>
+          <p:cNvSpPr txBox="1"/>
+          <p:nvPr/>
+        </p:nvSpPr>
+        <p:spPr>
+          <a:xfrm>
+            <a:off x="9820656" y="1700784"/>
+            <a:ext cx="1810512" cy="329184"/>
+          </a:xfrm>
+          <a:prstGeom prst="rect">
+            <a:avLst/>
+          </a:prstGeom>
+          <a:noFill/>
+          <a:ln/>
+        </p:spPr>
+        <p:txBody>
+          <a:bodyPr wrap="square" lIns="0" tIns="0" rIns="0" bIns="0" rtlCol="0" anchor="ctr"/>
+          <a:lstStyle/>
+          <a:p>
+            <a:pPr algn="ctr" indent="0" marL="0">
+              <a:buNone/>
+            </a:pPr>
+            <a:r>
+              <a:rPr lang="en-US" sz="1250" b="1" dirty="0">
+                <a:solidFill>
+                  <a:srgbClr val="FFFFFF"/>
+                </a:solidFill>
+                <a:latin typeface="Calibri" pitchFamily="34" charset="0"/>
+                <a:ea typeface="Calibri" pitchFamily="34" charset="-122"/>
+                <a:cs typeface="Calibri" pitchFamily="34" charset="-120"/>
+              </a:rPr>
+              <a:t>One run per cell</a:t>
+            </a:r>
+            <a:endParaRPr lang="en-US" sz="1250" dirty="0"/>
+          </a:p>
+        </p:txBody>
+      </p:sp>
+      <p:sp>
+        <p:nvSpPr>
+          <p:cNvPr id="22" name="Text 20"/>
+          <p:cNvSpPr txBox="1"/>
+          <p:nvPr/>
+        </p:nvSpPr>
+        <p:spPr>
+          <a:xfrm>
+            <a:off x="9820656" y="2066544"/>
+            <a:ext cx="1810512" cy="1261872"/>
+          </a:xfrm>
+          <a:prstGeom prst="rect">
+            <a:avLst/>
+          </a:prstGeom>
+          <a:noFill/>
+          <a:ln/>
+        </p:spPr>
+        <p:txBody>
+          <a:bodyPr wrap="square" lIns="0" tIns="0" rIns="0" bIns="0" rtlCol="0" anchor="ctr"/>
+          <a:lstStyle/>
+          <a:p>
+            <a:pPr algn="ctr" indent="0" marL="0">
+              <a:buNone/>
+            </a:pPr>
+            <a:r>
+              <a:rPr lang="en-US" sz="860" dirty="0">
+                <a:solidFill>
+                  <a:srgbClr val="F0F4FA"/>
+                </a:solidFill>
+                <a:latin typeface="Calibri" pitchFamily="34" charset="0"/>
+                <a:ea typeface="Calibri" pitchFamily="34" charset="-122"/>
+                <a:cs typeface="Calibri" pitchFamily="34" charset="-120"/>
+              </a:rPr>
+              <a:t>f-in-core relaxation gives</a:t>
+            </a:r>
+            <a:endParaRPr lang="en-US" sz="860" dirty="0"/>
+          </a:p>
+          <a:p>
+            <a:pPr algn="ctr" indent="0" marL="0">
+              <a:buNone/>
+            </a:pPr>
+            <a:r>
+              <a:rPr lang="en-US" sz="860" dirty="0">
+                <a:solidFill>
+                  <a:srgbClr val="F0F4FA"/>
+                </a:solidFill>
+                <a:latin typeface="Calibri" pitchFamily="34" charset="0"/>
+                <a:ea typeface="Calibri" pitchFamily="34" charset="-122"/>
+                <a:cs typeface="Calibri" pitchFamily="34" charset="-120"/>
+              </a:rPr>
+              <a:t>Ms, h → gap, T*; results</a:t>
+            </a:r>
+            <a:endParaRPr lang="en-US" sz="860" dirty="0"/>
+          </a:p>
+          <a:p>
+            <a:pPr algn="ctr" indent="0" marL="0">
+              <a:buNone/>
+            </a:pPr>
+            <a:r>
+              <a:rPr lang="en-US" sz="860" dirty="0">
+                <a:solidFill>
+                  <a:srgbClr val="F0F4FA"/>
+                </a:solidFill>
+                <a:latin typeface="Calibri" pitchFamily="34" charset="0"/>
+                <a:ea typeface="Calibri" pitchFamily="34" charset="-122"/>
+                <a:cs typeface="Calibri" pitchFamily="34" charset="-120"/>
+              </a:rPr>
+              <a:t>re-train every layer</a:t>
+            </a:r>
+            <a:endParaRPr lang="en-US" sz="860" dirty="0"/>
+          </a:p>
+        </p:txBody>
+      </p:sp>
+      <p:sp>
+        <p:nvSpPr>
+          <p:cNvPr id="23" name="Shape 21"/>
+          <p:cNvSpPr/>
+          <p:nvPr/>
+        </p:nvSpPr>
+        <p:spPr>
+          <a:xfrm>
+            <a:off x="10725912" y="3383280"/>
+            <a:ext cx="0" cy="457200"/>
+          </a:xfrm>
+          <a:prstGeom prst="line">
+            <a:avLst/>
+          </a:prstGeom>
+          <a:noFill/>
+          <a:ln w="19050">
+            <a:solidFill>
+              <a:srgbClr val="8FA3C0"/>
+            </a:solidFill>
+            <a:prstDash val="solid"/>
+          </a:ln>
+        </p:spPr>
+      </p:sp>
+      <p:sp>
+        <p:nvSpPr>
+          <p:cNvPr id="24" name="Shape 22"/>
+          <p:cNvSpPr/>
+          <p:nvPr/>
+        </p:nvSpPr>
+        <p:spPr>
+          <a:xfrm>
+            <a:off x="1655064" y="3840480"/>
+            <a:ext cx="9070848" cy="0"/>
+          </a:xfrm>
+          <a:prstGeom prst="line">
+            <a:avLst/>
+          </a:prstGeom>
+          <a:noFill/>
+          <a:ln w="19050">
+            <a:solidFill>
+              <a:srgbClr val="8FA3C0"/>
+            </a:solidFill>
+            <a:prstDash val="solid"/>
+          </a:ln>
+        </p:spPr>
+      </p:sp>
+      <p:sp>
+        <p:nvSpPr>
+          <p:cNvPr id="25" name="Shape 23"/>
+          <p:cNvSpPr/>
+          <p:nvPr/>
+        </p:nvSpPr>
+        <p:spPr>
+          <a:xfrm>
+            <a:off x="1655064" y="3383280"/>
+            <a:ext cx="0" cy="457200"/>
+          </a:xfrm>
+          <a:prstGeom prst="line">
+            <a:avLst/>
+          </a:prstGeom>
+          <a:noFill/>
+          <a:ln w="19050">
+            <a:solidFill>
+              <a:srgbClr val="8FA3C0"/>
+            </a:solidFill>
+            <a:prstDash val="solid"/>
+            <a:headEnd type="triangle"/>
+          </a:ln>
+        </p:spPr>
+      </p:sp>
+      <p:sp>
+        <p:nvSpPr>
+          <p:cNvPr id="26" name="Text 24"/>
+          <p:cNvSpPr txBox="1"/>
+          <p:nvPr/>
+        </p:nvSpPr>
+        <p:spPr>
+          <a:xfrm>
+            <a:off x="2468880" y="3877056"/>
+            <a:ext cx="7315200" cy="274320"/>
+          </a:xfrm>
+          <a:prstGeom prst="rect">
+            <a:avLst/>
+          </a:prstGeom>
+          <a:noFill/>
+          <a:ln/>
+        </p:spPr>
+        <p:txBody>
+          <a:bodyPr wrap="square" lIns="0" tIns="0" rIns="0" bIns="0" rtlCol="0" anchor="ctr"/>
+          <a:lstStyle/>
+          <a:p>
+            <a:pPr algn="ctr" indent="0" marL="0">
+              <a:buNone/>
+            </a:pPr>
+            <a:r>
+              <a:rPr lang="en-US" sz="1000" i="1" dirty="0">
+                <a:solidFill>
+                  <a:srgbClr val="8FA3C0"/>
+                </a:solidFill>
+                <a:latin typeface="Calibri" pitchFamily="34" charset="0"/>
+                <a:ea typeface="Calibri" pitchFamily="34" charset="-122"/>
+                <a:cs typeface="Calibri" pitchFamily="34" charset="-120"/>
+              </a:rPr>
+              <a:t>every batch is a designed experiment: it must move the GP posterior or test a causal edge, not just add points</a:t>
+            </a:r>
+            <a:endParaRPr lang="en-US" sz="1000" dirty="0"/>
+          </a:p>
+        </p:txBody>
+      </p:sp>
+      <p:sp>
+        <p:nvSpPr>
+          <p:cNvPr id="27" name="Shape 25"/>
+          <p:cNvSpPr/>
+          <p:nvPr/>
+        </p:nvSpPr>
+        <p:spPr>
+          <a:xfrm>
+            <a:off x="640080" y="4297680"/>
+            <a:ext cx="5577840" cy="1920240"/>
+          </a:xfrm>
+          <a:prstGeom prst="roundRect">
+            <a:avLst>
+              <a:gd name="adj" fmla="val 2857"/>
+            </a:avLst>
+          </a:prstGeom>
+          <a:solidFill>
+            <a:srgbClr val="1B2A4A"/>
+          </a:solidFill>
+          <a:ln/>
+        </p:spPr>
+      </p:sp>
+      <p:sp>
+        <p:nvSpPr>
+          <p:cNvPr id="28" name="Text 26"/>
+          <p:cNvSpPr txBox="1"/>
+          <p:nvPr/>
+        </p:nvSpPr>
+        <p:spPr>
+          <a:xfrm>
+            <a:off x="822960" y="4389120"/>
+            <a:ext cx="5212080" cy="256032"/>
+          </a:xfrm>
+          <a:prstGeom prst="rect">
+            <a:avLst/>
+          </a:prstGeom>
+          <a:noFill/>
+          <a:ln/>
+        </p:spPr>
+        <p:txBody>
+          <a:bodyPr wrap="square" lIns="0" tIns="0" rIns="0" bIns="0" rtlCol="0" anchor="ctr"/>
+          <a:lstStyle/>
+          <a:p>
+            <a:pPr indent="0" marL="0">
+              <a:buNone/>
+            </a:pPr>
+            <a:r>
+              <a:rPr lang="en-US" sz="1150" b="1" dirty="0">
+                <a:solidFill>
+                  <a:srgbClr val="F2B134"/>
+                </a:solidFill>
+                <a:latin typeface="Calibri" pitchFamily="34" charset="0"/>
+                <a:ea typeface="Calibri" pitchFamily="34" charset="-122"/>
+                <a:cs typeface="Calibri" pitchFamily="34" charset="-120"/>
+              </a:rPr>
+              <a:t>The causal model the data support</a:t>
+            </a:r>
+            <a:endParaRPr lang="en-US" sz="1150" dirty="0"/>
+          </a:p>
+        </p:txBody>
+      </p:sp>
+      <p:sp>
+        <p:nvSpPr>
+          <p:cNvPr id="29" name="Shape 27"/>
+          <p:cNvSpPr/>
+          <p:nvPr/>
+        </p:nvSpPr>
+        <p:spPr>
+          <a:xfrm>
+            <a:off x="868680" y="4800600"/>
+            <a:ext cx="1417320" cy="530352"/>
+          </a:xfrm>
+          <a:prstGeom prst="roundRect">
+            <a:avLst>
+              <a:gd name="adj" fmla="val 13793"/>
+            </a:avLst>
+          </a:prstGeom>
+          <a:solidFill>
+            <a:srgbClr val="2E86AB"/>
+          </a:solidFill>
+          <a:ln/>
+        </p:spPr>
+      </p:sp>
+      <p:sp>
+        <p:nvSpPr>
+          <p:cNvPr id="30" name="Text 28"/>
+          <p:cNvSpPr txBox="1"/>
+          <p:nvPr/>
+        </p:nvSpPr>
+        <p:spPr>
+          <a:xfrm>
+            <a:off x="868680" y="4800600"/>
+            <a:ext cx="1417320" cy="530352"/>
+          </a:xfrm>
+          <a:prstGeom prst="rect">
+            <a:avLst/>
+          </a:prstGeom>
+          <a:noFill/>
+          <a:ln/>
+        </p:spPr>
+        <p:txBody>
+          <a:bodyPr wrap="square" lIns="0" tIns="0" rIns="0" bIns="0" rtlCol="0" anchor="ctr"/>
+          <a:lstStyle/>
+          <a:p>
+            <a:pPr algn="ctr" indent="0" marL="0">
+              <a:buNone/>
+            </a:pPr>
+            <a:r>
+              <a:rPr lang="en-US" sz="800" b="1" dirty="0">
+                <a:solidFill>
+                  <a:srgbClr val="FFFFFF"/>
+                </a:solidFill>
+                <a:latin typeface="Calibri" pitchFamily="34" charset="0"/>
+                <a:ea typeface="Calibri" pitchFamily="34" charset="-122"/>
+                <a:cs typeface="Calibri" pitchFamily="34" charset="-120"/>
+              </a:rPr>
+              <a:t>RE-TM distance</a:t>
+            </a:r>
+            <a:endParaRPr lang="en-US" sz="800" dirty="0"/>
+          </a:p>
+          <a:p>
+            <a:pPr algn="ctr" indent="0" marL="0">
+              <a:buNone/>
+            </a:pPr>
+            <a:r>
+              <a:rPr lang="en-US" sz="800" b="1" dirty="0">
+                <a:solidFill>
+                  <a:srgbClr val="FFFFFF"/>
+                </a:solidFill>
+                <a:latin typeface="Calibri" pitchFamily="34" charset="0"/>
+                <a:ea typeface="Calibri" pitchFamily="34" charset="-122"/>
+                <a:cs typeface="Calibri" pitchFamily="34" charset="-120"/>
+              </a:rPr>
+              <a:t>coordination</a:t>
+            </a:r>
+            <a:endParaRPr lang="en-US" sz="800" dirty="0"/>
+          </a:p>
+        </p:txBody>
+      </p:sp>
+      <p:sp>
+        <p:nvSpPr>
+          <p:cNvPr id="31" name="Shape 29"/>
+          <p:cNvSpPr/>
+          <p:nvPr/>
+        </p:nvSpPr>
+        <p:spPr>
+          <a:xfrm>
+            <a:off x="868680" y="5440680"/>
+            <a:ext cx="1417320" cy="530352"/>
+          </a:xfrm>
+          <a:prstGeom prst="roundRect">
+            <a:avLst>
+              <a:gd name="adj" fmla="val 13793"/>
+            </a:avLst>
+          </a:prstGeom>
+          <a:solidFill>
+            <a:srgbClr val="2E86AB"/>
+          </a:solidFill>
+          <a:ln/>
+        </p:spPr>
+      </p:sp>
+      <p:sp>
+        <p:nvSpPr>
+          <p:cNvPr id="32" name="Text 30"/>
+          <p:cNvSpPr txBox="1"/>
+          <p:nvPr/>
+        </p:nvSpPr>
+        <p:spPr>
+          <a:xfrm>
+            <a:off x="868680" y="5440680"/>
+            <a:ext cx="1417320" cy="530352"/>
+          </a:xfrm>
+          <a:prstGeom prst="rect">
+            <a:avLst/>
+          </a:prstGeom>
+          <a:noFill/>
+          <a:ln/>
+        </p:spPr>
+        <p:txBody>
+          <a:bodyPr wrap="square" lIns="0" tIns="0" rIns="0" bIns="0" rtlCol="0" anchor="ctr"/>
+          <a:lstStyle/>
+          <a:p>
+            <a:pPr algn="ctr" indent="0" marL="0">
+              <a:buNone/>
+            </a:pPr>
+            <a:r>
+              <a:rPr lang="en-US" sz="800" b="1" dirty="0">
+                <a:solidFill>
+                  <a:srgbClr val="FFFFFF"/>
+                </a:solidFill>
+                <a:latin typeface="Calibri" pitchFamily="34" charset="0"/>
+                <a:ea typeface="Calibri" pitchFamily="34" charset="-122"/>
+                <a:cs typeface="Calibri" pitchFamily="34" charset="-120"/>
+              </a:rPr>
+              <a:t>Fe / Co mix</a:t>
+            </a:r>
+            <a:endParaRPr lang="en-US" sz="800" dirty="0"/>
+          </a:p>
+          <a:p>
+            <a:pPr algn="ctr" indent="0" marL="0">
+              <a:buNone/>
+            </a:pPr>
+            <a:r>
+              <a:rPr lang="en-US" sz="800" b="1" dirty="0">
+                <a:solidFill>
+                  <a:srgbClr val="FFFFFF"/>
+                </a:solidFill>
+                <a:latin typeface="Calibri" pitchFamily="34" charset="0"/>
+                <a:ea typeface="Calibri" pitchFamily="34" charset="-122"/>
+                <a:cs typeface="Calibri" pitchFamily="34" charset="-120"/>
+              </a:rPr>
+              <a:t>interstitial site</a:t>
+            </a:r>
+            <a:endParaRPr lang="en-US" sz="800" dirty="0"/>
+          </a:p>
+        </p:txBody>
+      </p:sp>
+      <p:sp>
+        <p:nvSpPr>
+          <p:cNvPr id="33" name="Shape 31"/>
+          <p:cNvSpPr/>
+          <p:nvPr/>
+        </p:nvSpPr>
+        <p:spPr>
+          <a:xfrm>
+            <a:off x="2788920" y="5120640"/>
+            <a:ext cx="1417320" cy="530352"/>
+          </a:xfrm>
+          <a:prstGeom prst="roundRect">
+            <a:avLst>
+              <a:gd name="adj" fmla="val 13793"/>
+            </a:avLst>
+          </a:prstGeom>
+          <a:solidFill>
+            <a:srgbClr val="F2B134"/>
+          </a:solidFill>
+          <a:ln/>
+        </p:spPr>
+      </p:sp>
+      <p:sp>
+        <p:nvSpPr>
+          <p:cNvPr id="34" name="Text 32"/>
+          <p:cNvSpPr txBox="1"/>
+          <p:nvPr/>
+        </p:nvSpPr>
+        <p:spPr>
+          <a:xfrm>
+            <a:off x="2788920" y="5120640"/>
+            <a:ext cx="1417320" cy="530352"/>
+          </a:xfrm>
+          <a:prstGeom prst="rect">
+            <a:avLst/>
+          </a:prstGeom>
+          <a:noFill/>
+          <a:ln/>
+        </p:spPr>
+        <p:txBody>
+          <a:bodyPr wrap="square" lIns="0" tIns="0" rIns="0" bIns="0" rtlCol="0" anchor="ctr"/>
+          <a:lstStyle/>
+          <a:p>
+            <a:pPr algn="ctr" indent="0" marL="0">
+              <a:buNone/>
+            </a:pPr>
+            <a:r>
+              <a:rPr lang="en-US" sz="800" b="1" dirty="0">
+                <a:solidFill>
+                  <a:srgbClr val="FFFFFF"/>
+                </a:solidFill>
+                <a:latin typeface="Calibri" pitchFamily="34" charset="0"/>
+                <a:ea typeface="Calibri" pitchFamily="34" charset="-122"/>
+                <a:cs typeface="Calibri" pitchFamily="34" charset="-120"/>
+              </a:rPr>
+              <a:t>S₅d on the RE</a:t>
+            </a:r>
+            <a:endParaRPr lang="en-US" sz="800" dirty="0"/>
+          </a:p>
+          <a:p>
+            <a:pPr algn="ctr" indent="0" marL="0">
+              <a:buNone/>
+            </a:pPr>
+            <a:r>
+              <a:rPr lang="en-US" sz="800" b="1" dirty="0">
+                <a:solidFill>
+                  <a:srgbClr val="FFFFFF"/>
+                </a:solidFill>
+                <a:latin typeface="Calibri" pitchFamily="34" charset="0"/>
+                <a:ea typeface="Calibri" pitchFamily="34" charset="-122"/>
+                <a:cs typeface="Calibri" pitchFamily="34" charset="-120"/>
+              </a:rPr>
+              <a:t>(h)</a:t>
+            </a:r>
+            <a:endParaRPr lang="en-US" sz="800" dirty="0"/>
+          </a:p>
+        </p:txBody>
+      </p:sp>
+      <p:sp>
+        <p:nvSpPr>
+          <p:cNvPr id="35" name="Shape 33"/>
+          <p:cNvSpPr/>
+          <p:nvPr/>
+        </p:nvSpPr>
+        <p:spPr>
+          <a:xfrm>
+            <a:off x="4572000" y="4800600"/>
+            <a:ext cx="1417320" cy="530352"/>
+          </a:xfrm>
+          <a:prstGeom prst="roundRect">
+            <a:avLst>
+              <a:gd name="adj" fmla="val 13793"/>
+            </a:avLst>
+          </a:prstGeom>
+          <a:solidFill>
+            <a:srgbClr val="E4572E"/>
+          </a:solidFill>
+          <a:ln/>
+        </p:spPr>
+      </p:sp>
+      <p:sp>
+        <p:nvSpPr>
+          <p:cNvPr id="36" name="Text 34"/>
+          <p:cNvSpPr txBox="1"/>
+          <p:nvPr/>
+        </p:nvSpPr>
+        <p:spPr>
+          <a:xfrm>
+            <a:off x="4572000" y="4800600"/>
+            <a:ext cx="1417320" cy="530352"/>
+          </a:xfrm>
+          <a:prstGeom prst="rect">
+            <a:avLst/>
+          </a:prstGeom>
+          <a:noFill/>
+          <a:ln/>
+        </p:spPr>
+        <p:txBody>
+          <a:bodyPr wrap="square" lIns="0" tIns="0" rIns="0" bIns="0" rtlCol="0" anchor="ctr"/>
+          <a:lstStyle/>
+          <a:p>
+            <a:pPr algn="ctr" indent="0" marL="0">
+              <a:buNone/>
+            </a:pPr>
+            <a:r>
+              <a:rPr lang="en-US" sz="800" b="1" dirty="0">
+                <a:solidFill>
+                  <a:srgbClr val="FFFFFF"/>
+                </a:solidFill>
+                <a:latin typeface="Calibri" pitchFamily="34" charset="0"/>
+                <a:ea typeface="Calibri" pitchFamily="34" charset="-122"/>
+                <a:cs typeface="Calibri" pitchFamily="34" charset="-120"/>
+              </a:rPr>
+              <a:t>RE-TM gap</a:t>
+            </a:r>
+            <a:endParaRPr lang="en-US" sz="800" dirty="0"/>
+          </a:p>
+          <a:p>
+            <a:pPr algn="ctr" indent="0" marL="0">
+              <a:buNone/>
+            </a:pPr>
+            <a:r>
+              <a:rPr lang="en-US" sz="800" b="1" dirty="0">
+                <a:solidFill>
+                  <a:srgbClr val="FFFFFF"/>
+                </a:solidFill>
+                <a:latin typeface="Calibri" pitchFamily="34" charset="0"/>
+                <a:ea typeface="Calibri" pitchFamily="34" charset="-122"/>
+                <a:cs typeface="Calibri" pitchFamily="34" charset="-120"/>
+              </a:rPr>
+              <a:t>T*, anisotropy lock</a:t>
+            </a:r>
+            <a:endParaRPr lang="en-US" sz="800" dirty="0"/>
+          </a:p>
+        </p:txBody>
+      </p:sp>
+      <p:sp>
+        <p:nvSpPr>
+          <p:cNvPr id="37" name="Shape 35"/>
+          <p:cNvSpPr/>
+          <p:nvPr/>
+        </p:nvSpPr>
+        <p:spPr>
+          <a:xfrm>
+            <a:off x="4572000" y="5440680"/>
+            <a:ext cx="1417320" cy="530352"/>
+          </a:xfrm>
+          <a:prstGeom prst="roundRect">
+            <a:avLst>
+              <a:gd name="adj" fmla="val 13793"/>
+            </a:avLst>
+          </a:prstGeom>
+          <a:solidFill>
+            <a:srgbClr val="E4572E"/>
+          </a:solidFill>
+          <a:ln/>
+        </p:spPr>
+      </p:sp>
+      <p:sp>
+        <p:nvSpPr>
+          <p:cNvPr id="38" name="Text 36"/>
+          <p:cNvSpPr txBox="1"/>
+          <p:nvPr/>
+        </p:nvSpPr>
+        <p:spPr>
+          <a:xfrm>
+            <a:off x="4572000" y="5440680"/>
+            <a:ext cx="1417320" cy="530352"/>
+          </a:xfrm>
+          <a:prstGeom prst="rect">
+            <a:avLst/>
+          </a:prstGeom>
+          <a:noFill/>
+          <a:ln/>
+        </p:spPr>
+        <p:txBody>
+          <a:bodyPr wrap="square" lIns="0" tIns="0" rIns="0" bIns="0" rtlCol="0" anchor="ctr"/>
+          <a:lstStyle/>
+          <a:p>
+            <a:pPr algn="ctr" indent="0" marL="0">
+              <a:buNone/>
+            </a:pPr>
+            <a:r>
+              <a:rPr lang="en-US" sz="800" b="1" dirty="0">
+                <a:solidFill>
+                  <a:srgbClr val="FFFFFF"/>
+                </a:solidFill>
+                <a:latin typeface="Calibri" pitchFamily="34" charset="0"/>
+                <a:ea typeface="Calibri" pitchFamily="34" charset="-122"/>
+                <a:cs typeface="Calibri" pitchFamily="34" charset="-120"/>
+              </a:rPr>
+              <a:t>Ms</a:t>
+            </a:r>
+            <a:endParaRPr lang="en-US" sz="800" dirty="0"/>
+          </a:p>
+          <a:p>
+            <a:pPr algn="ctr" indent="0" marL="0">
+              <a:buNone/>
+            </a:pPr>
+            <a:r>
+              <a:rPr lang="en-US" sz="800" b="1" dirty="0">
+                <a:solidFill>
+                  <a:srgbClr val="FFFFFF"/>
+                </a:solidFill>
+                <a:latin typeface="Calibri" pitchFamily="34" charset="0"/>
+                <a:ea typeface="Calibri" pitchFamily="34" charset="-122"/>
+                <a:cs typeface="Calibri" pitchFamily="34" charset="-120"/>
+              </a:rPr>
+              <a:t>(Fe density + RE)</a:t>
+            </a:r>
+            <a:endParaRPr lang="en-US" sz="800" dirty="0"/>
+          </a:p>
+        </p:txBody>
+      </p:sp>
+      <p:sp>
+        <p:nvSpPr>
+          <p:cNvPr id="39" name="Shape 37"/>
+          <p:cNvSpPr/>
+          <p:nvPr/>
+        </p:nvSpPr>
+        <p:spPr>
+          <a:xfrm>
+            <a:off x="2286000" y="5065776"/>
+            <a:ext cx="502920" cy="219456"/>
+          </a:xfrm>
+          <a:prstGeom prst="line">
+            <a:avLst/>
+          </a:prstGeom>
+          <a:noFill/>
+          <a:ln w="17780">
+            <a:solidFill>
+              <a:srgbClr val="C6D2E4"/>
+            </a:solidFill>
+            <a:prstDash val="solid"/>
+            <a:tailEnd type="triangle"/>
+          </a:ln>
+        </p:spPr>
+      </p:sp>
+      <p:sp>
+        <p:nvSpPr>
+          <p:cNvPr id="40" name="Shape 38"/>
+          <p:cNvSpPr/>
+          <p:nvPr/>
+        </p:nvSpPr>
+        <p:spPr>
+          <a:xfrm>
+            <a:off x="2286000" y="5705856"/>
+            <a:ext cx="502920" cy="-219456"/>
+          </a:xfrm>
+          <a:prstGeom prst="line">
+            <a:avLst/>
+          </a:prstGeom>
+          <a:noFill/>
+          <a:ln w="17780">
+            <a:solidFill>
+              <a:srgbClr val="C6D2E4"/>
+            </a:solidFill>
+            <a:prstDash val="solid"/>
+            <a:tailEnd type="triangle"/>
+          </a:ln>
+        </p:spPr>
+      </p:sp>
+      <p:sp>
+        <p:nvSpPr>
+          <p:cNvPr id="41" name="Shape 39"/>
+          <p:cNvSpPr/>
+          <p:nvPr/>
+        </p:nvSpPr>
+        <p:spPr>
+          <a:xfrm>
+            <a:off x="4206240" y="5285232"/>
+            <a:ext cx="365760" cy="-201168"/>
+          </a:xfrm>
+          <a:prstGeom prst="line">
+            <a:avLst/>
+          </a:prstGeom>
+          <a:noFill/>
+          <a:ln w="17780">
+            <a:solidFill>
+              <a:srgbClr val="C6D2E4"/>
+            </a:solidFill>
+            <a:prstDash val="solid"/>
+            <a:tailEnd type="triangle"/>
+          </a:ln>
+        </p:spPr>
+      </p:sp>
+      <p:sp>
+        <p:nvSpPr>
+          <p:cNvPr id="42" name="Shape 40"/>
+          <p:cNvSpPr/>
+          <p:nvPr/>
+        </p:nvSpPr>
+        <p:spPr>
+          <a:xfrm>
+            <a:off x="2286000" y="5760720"/>
+            <a:ext cx="2286000" cy="0"/>
+          </a:xfrm>
+          <a:prstGeom prst="line">
+            <a:avLst/>
+          </a:prstGeom>
+          <a:noFill/>
+          <a:ln w="17780">
+            <a:solidFill>
+              <a:srgbClr val="C6D2E4"/>
+            </a:solidFill>
+            <a:prstDash val="dash"/>
+            <a:tailEnd type="triangle"/>
+          </a:ln>
+        </p:spPr>
+      </p:sp>
+      <p:sp>
+        <p:nvSpPr>
+          <p:cNvPr id="43" name="Text 41"/>
+          <p:cNvSpPr txBox="1"/>
+          <p:nvPr/>
+        </p:nvSpPr>
+        <p:spPr>
+          <a:xfrm>
+            <a:off x="822960" y="6035040"/>
+            <a:ext cx="5212080" cy="182880"/>
+          </a:xfrm>
+          <a:prstGeom prst="rect">
+            <a:avLst/>
+          </a:prstGeom>
+          <a:noFill/>
+          <a:ln/>
+        </p:spPr>
+        <p:txBody>
+          <a:bodyPr wrap="square" lIns="0" tIns="0" rIns="0" bIns="0" rtlCol="0" anchor="ctr"/>
+          <a:lstStyle/>
+          <a:p>
+            <a:pPr indent="0" marL="0">
+              <a:buNone/>
+            </a:pPr>
+            <a:r>
+              <a:rPr lang="en-US" sz="760" i="1" dirty="0">
+                <a:solidFill>
+                  <a:srgbClr val="AEBBD0"/>
+                </a:solidFill>
+                <a:latin typeface="Calibri" pitchFamily="34" charset="0"/>
+                <a:ea typeface="Calibri" pitchFamily="34" charset="-122"/>
+                <a:cs typeface="Calibri" pitchFamily="34" charset="-120"/>
+              </a:rPr>
+              <a:t>mediator: every host lever acts through S₅d (r = 0.89); Ms is set separately by Fe density and the RE. Interventions on the left are what a generative model may propose; the dashed edge is the Co trade-off.</a:t>
+            </a:r>
+            <a:endParaRPr lang="en-US" sz="760" dirty="0"/>
+          </a:p>
+        </p:txBody>
+      </p:sp>
+      <p:sp>
+        <p:nvSpPr>
+          <p:cNvPr id="44" name="Shape 42"/>
+          <p:cNvSpPr/>
+          <p:nvPr/>
+        </p:nvSpPr>
+        <p:spPr>
+          <a:xfrm>
+            <a:off x="6400800" y="4297680"/>
+            <a:ext cx="2514600" cy="1920240"/>
+          </a:xfrm>
+          <a:prstGeom prst="roundRect">
+            <a:avLst>
+              <a:gd name="adj" fmla="val 2857"/>
+            </a:avLst>
+          </a:prstGeom>
+          <a:solidFill>
+            <a:srgbClr val="1B2A4A"/>
+          </a:solidFill>
+          <a:ln/>
+        </p:spPr>
+      </p:sp>
+      <p:sp>
+        <p:nvSpPr>
+          <p:cNvPr id="45" name="Text 43"/>
+          <p:cNvSpPr txBox="1"/>
+          <p:nvPr/>
+        </p:nvSpPr>
+        <p:spPr>
+          <a:xfrm>
+            <a:off x="6565392" y="4389120"/>
+            <a:ext cx="2194560" cy="274320"/>
+          </a:xfrm>
+          <a:prstGeom prst="rect">
+            <a:avLst/>
+          </a:prstGeom>
+          <a:noFill/>
+          <a:ln/>
+        </p:spPr>
+        <p:txBody>
+          <a:bodyPr wrap="square" lIns="0" tIns="0" rIns="0" bIns="0" rtlCol="0" anchor="ctr"/>
+          <a:lstStyle/>
+          <a:p>
+            <a:pPr indent="0" marL="0">
+              <a:buNone/>
+            </a:pPr>
+            <a:r>
+              <a:rPr lang="en-US" sz="1150" b="1" dirty="0">
+                <a:solidFill>
+                  <a:srgbClr val="F2B134"/>
+                </a:solidFill>
+                <a:latin typeface="Calibri" pitchFamily="34" charset="0"/>
+                <a:ea typeface="Calibri" pitchFamily="34" charset="-122"/>
+                <a:cs typeface="Calibri" pitchFamily="34" charset="-120"/>
+              </a:rPr>
+              <a:t>Gaussian process</a:t>
+            </a:r>
+            <a:endParaRPr lang="en-US" sz="1150" dirty="0"/>
+          </a:p>
+        </p:txBody>
+      </p:sp>
+      <p:sp>
+        <p:nvSpPr>
+          <p:cNvPr id="46" name="Text 44"/>
+          <p:cNvSpPr txBox="1"/>
+          <p:nvPr/>
+        </p:nvSpPr>
+        <p:spPr>
+          <a:xfrm>
+            <a:off x="6565392" y="4681728"/>
+            <a:ext cx="2212848" cy="1481328"/>
+          </a:xfrm>
+          <a:prstGeom prst="rect">
+            <a:avLst/>
+          </a:prstGeom>
+          <a:noFill/>
+          <a:ln/>
+        </p:spPr>
+        <p:txBody>
+          <a:bodyPr wrap="square" lIns="0" tIns="0" rIns="0" bIns="0" rtlCol="0" anchor="ctr"/>
+          <a:lstStyle/>
+          <a:p>
+            <a:pPr indent="0" marL="0">
+              <a:buNone/>
+            </a:pPr>
+            <a:r>
+              <a:rPr lang="en-US" sz="840" dirty="0">
+                <a:solidFill>
+                  <a:srgbClr val="C6D2E4"/>
+                </a:solidFill>
+                <a:latin typeface="Calibri" pitchFamily="34" charset="0"/>
+                <a:ea typeface="Calibri" pitchFamily="34" charset="-122"/>
+                <a:cs typeface="Calibri" pitchFamily="34" charset="-120"/>
+              </a:rPr>
+              <a:t>180 points, smooth physics descriptors, batch size fixed by one packed job. Mean function = 1574·h so the GP learns residuals; q-EI with a diversity penalty picks each batch. Each label is now ONE f-in-core run, so a round is 150-200 compounds per 25-node job.</a:t>
+            </a:r>
+            <a:endParaRPr lang="en-US" sz="840" dirty="0"/>
+          </a:p>
+        </p:txBody>
+      </p:sp>
+      <p:sp>
+        <p:nvSpPr>
+          <p:cNvPr id="47" name="Shape 45"/>
+          <p:cNvSpPr/>
+          <p:nvPr/>
+        </p:nvSpPr>
+        <p:spPr>
+          <a:xfrm>
+            <a:off x="9006840" y="4297680"/>
+            <a:ext cx="2514600" cy="1920240"/>
+          </a:xfrm>
+          <a:prstGeom prst="roundRect">
+            <a:avLst>
+              <a:gd name="adj" fmla="val 2857"/>
+            </a:avLst>
+          </a:prstGeom>
+          <a:solidFill>
+            <a:srgbClr val="1B2A4A"/>
+          </a:solidFill>
+          <a:ln/>
+        </p:spPr>
+      </p:sp>
+      <p:sp>
+        <p:nvSpPr>
+          <p:cNvPr id="48" name="Text 46"/>
+          <p:cNvSpPr txBox="1"/>
+          <p:nvPr/>
+        </p:nvSpPr>
+        <p:spPr>
+          <a:xfrm>
+            <a:off x="9171432" y="4389120"/>
+            <a:ext cx="2194560" cy="274320"/>
+          </a:xfrm>
+          <a:prstGeom prst="rect">
+            <a:avLst/>
+          </a:prstGeom>
+          <a:noFill/>
+          <a:ln/>
+        </p:spPr>
+        <p:txBody>
+          <a:bodyPr wrap="square" lIns="0" tIns="0" rIns="0" bIns="0" rtlCol="0" anchor="ctr"/>
+          <a:lstStyle/>
+          <a:p>
+            <a:pPr indent="0" marL="0">
+              <a:buNone/>
+            </a:pPr>
+            <a:r>
+              <a:rPr lang="en-US" sz="1150" b="1" dirty="0">
+                <a:solidFill>
+                  <a:srgbClr val="F2B134"/>
+                </a:solidFill>
+                <a:latin typeface="Calibri" pitchFamily="34" charset="0"/>
+                <a:ea typeface="Calibri" pitchFamily="34" charset="-122"/>
+                <a:cs typeface="Calibri" pitchFamily="34" charset="-120"/>
+              </a:rPr>
+              <a:t>Generative + causal</a:t>
+            </a:r>
+            <a:endParaRPr lang="en-US" sz="1150" dirty="0"/>
+          </a:p>
+        </p:txBody>
+      </p:sp>
+      <p:sp>
+        <p:nvSpPr>
+          <p:cNvPr id="49" name="Text 47"/>
+          <p:cNvSpPr txBox="1"/>
+          <p:nvPr/>
+        </p:nvSpPr>
+        <p:spPr>
+          <a:xfrm>
+            <a:off x="9171432" y="4681728"/>
+            <a:ext cx="2212848" cy="1481328"/>
+          </a:xfrm>
+          <a:prstGeom prst="rect">
+            <a:avLst/>
+          </a:prstGeom>
+          <a:noFill/>
+          <a:ln/>
+        </p:spPr>
+        <p:txBody>
+          <a:bodyPr wrap="square" lIns="0" tIns="0" rIns="0" bIns="0" rtlCol="0" anchor="ctr"/>
+          <a:lstStyle/>
+          <a:p>
+            <a:pPr indent="0" marL="0">
+              <a:buNone/>
+            </a:pPr>
+            <a:r>
+              <a:rPr lang="en-US" sz="840" dirty="0">
+                <a:solidFill>
+                  <a:srgbClr val="C6D2E4"/>
+                </a:solidFill>
+                <a:latin typeface="Calibri" pitchFamily="34" charset="0"/>
+                <a:ea typeface="Calibri" pitchFamily="34" charset="-122"/>
+                <a:cs typeface="Calibri" pitchFamily="34" charset="-120"/>
+              </a:rPr>
+              <a:t>The pool is exhausted above ≈ 1.75 T. A diffusion model conditioned on the causal parents - dense Fe, RE-TM &lt; 3.0 Å, 12-fold coordination, partial Co, no H in the RE shell - proposes frameworks; MACE hull filters; the causal graph tells it which knobs are real and which are confounded.</a:t>
+            </a:r>
+            <a:endParaRPr lang="en-US" sz="840" dirty="0"/>
+          </a:p>
+        </p:txBody>
+      </p:sp>
+      <p:sp>
+        <p:nvSpPr>
+          <p:cNvPr id="50" name="Text 48"/>
+          <p:cNvSpPr txBox="1"/>
+          <p:nvPr/>
+        </p:nvSpPr>
+        <p:spPr>
+          <a:xfrm>
+            <a:off x="640080" y="6327648"/>
+            <a:ext cx="10881360" cy="320040"/>
+          </a:xfrm>
+          <a:prstGeom prst="rect">
+            <a:avLst/>
+          </a:prstGeom>
+          <a:noFill/>
+          <a:ln/>
+        </p:spPr>
+        <p:txBody>
+          <a:bodyPr wrap="square" lIns="0" tIns="0" rIns="0" bIns="0" rtlCol="0" anchor="ctr"/>
+          <a:lstStyle/>
+          <a:p>
+            <a:pPr indent="0" marL="0">
+              <a:buNone/>
+            </a:pPr>
+            <a:r>
+              <a:rPr lang="en-US" sz="1100" i="1" dirty="0">
+                <a:solidFill>
+                  <a:srgbClr val="8FA3C0"/>
+                </a:solidFill>
+                <a:latin typeface="Calibri" pitchFamily="34" charset="0"/>
+                <a:ea typeface="Calibri" pitchFamily="34" charset="-122"/>
+                <a:cs typeface="Calibri" pitchFamily="34" charset="-120"/>
+              </a:rPr>
+              <a:t>The campaign's product is not a compound; it is a calibrated instrument for RE-TM exchange and the first dataset a learning loop can be trained on.</a:t>
+            </a:r>
+            <a:endParaRPr lang="en-US" sz="1100" dirty="0"/>
           </a:p>
         </p:txBody>
       </p:sp>

</xml_diff>